<commit_message>
Rework the Web service deck into a sales structure: problem, solution, benefits, rollout, demo ask
Co-Authored-By: Claude Opus 5.5 <noreply@anthropic.com>
Claude-Session: https://claude.ai/code/session_012KB9rzS4jFaqH8bW6v7YFy
</commit_message>
<xml_diff>
--- a/docs/deck/U-Speak_Web版_サービス資料.pptx
+++ b/docs/deck/U-Speak_Web版_サービス資料.pptx
@@ -11,6 +11,8 @@
     <p:sldId id="259" r:id="rId10"/>
     <p:sldId id="260" r:id="rId11"/>
     <p:sldId id="261" r:id="rId12"/>
+    <p:sldId id="262" r:id="rId13"/>
+    <p:sldId id="263" r:id="rId14"/>
   </p:sldIdLst>
   <p:sldSz cx="9144000" cy="5143500" type="screen4x3"/>
   <p:notesSz cx="6858000" cy="9144000"/>
@@ -3153,7 +3155,7 @@
         </p:nvSpPr>
         <p:spPr>
           <a:xfrm>
-            <a:off x="502920" y="822960"/>
+            <a:off x="502920" y="685800"/>
             <a:ext cx="3383280" cy="365760"/>
           </a:xfrm>
           <a:prstGeom prst="rect">
@@ -3175,7 +3177,7 @@
                 </a:solidFill>
                 <a:latin typeface="Noto Sans JP"/>
               </a:rPr>
-              <a:t>合同会社 U-Speak Lab</a:t>
+              <a:t>英会話教室のための英語プラットフォーム</a:t>
             </a:r>
           </a:p>
         </p:txBody>
@@ -3188,7 +3190,7 @@
         </p:nvSpPr>
         <p:spPr>
           <a:xfrm>
-            <a:off x="457200" y="1234440"/>
+            <a:off x="457200" y="1097280"/>
             <a:ext cx="3611880" cy="731520"/>
           </a:xfrm>
           <a:prstGeom prst="rect">
@@ -3223,8 +3225,8 @@
         </p:nvSpPr>
         <p:spPr>
           <a:xfrm>
-            <a:off x="502920" y="2148840"/>
-            <a:ext cx="3291840" cy="1097280"/>
+            <a:off x="502920" y="1965960"/>
+            <a:ext cx="3291840" cy="1188720"/>
           </a:xfrm>
           <a:prstGeom prst="rect">
             <a:avLst/>
@@ -3239,13 +3241,13 @@
           <a:p>
             <a:pPr algn="l"/>
             <a:r>
-              <a:rPr sz="1800" b="0">
+              <a:rPr sz="1900" b="1">
                 <a:solidFill>
                   <a:srgbClr val="FFF6E6"/>
                 </a:solidFill>
                 <a:latin typeface="Noto Sans JP"/>
               </a:rPr>
-              <a:t>英語で遊ぶ3Dの島と、教室・家庭をつなぐ学習記録</a:t>
+              <a:t>生徒が家でも英語を続け、その成果が保護者に毎週届く</a:t>
             </a:r>
           </a:p>
         </p:txBody>
@@ -3278,13 +3280,13 @@
               </a:spcAft>
             </a:pPr>
             <a:r>
-              <a:rPr sz="1400" b="0">
+              <a:rPr sz="1300" b="0">
                 <a:solidFill>
                   <a:srgbClr val="C9D6CC"/>
                 </a:solidFill>
                 <a:latin typeface="Noto Sans JP"/>
               </a:rPr>
-              <a:t>サービス資料</a:t>
+              <a:t>合同会社 U-Speak Lab</a:t>
             </a:r>
           </a:p>
           <a:p>
@@ -3294,13 +3296,13 @@
               </a:spcAft>
             </a:pPr>
             <a:r>
-              <a:rPr sz="1400" b="0">
+              <a:rPr sz="1300" b="0">
                 <a:solidFill>
                   <a:srgbClr val="C9D6CC"/>
                 </a:solidFill>
                 <a:latin typeface="Noto Sans JP"/>
               </a:rPr>
-              <a:t>ブラウザだけで動く（iPad・PC）</a:t>
+              <a:t>iPad・PCのブラウザで動作（インストール不要）</a:t>
             </a:r>
           </a:p>
         </p:txBody>
@@ -3359,7 +3361,7 @@
                 </a:solidFill>
                 <a:latin typeface="Noto Sans JP"/>
               </a:rPr>
-              <a:t>メインの島（英単語ハウス・お店・ゲート）と、橋でつながるU-Speak島</a:t>
+              <a:t>メインの島：歩いて英語を使う3Dの世界</a:t>
             </a:r>
           </a:p>
         </p:txBody>
@@ -3420,45 +3422,120 @@
                 </a:solidFill>
                 <a:latin typeface="Noto Sans JP"/>
               </a:rPr>
-              <a:t>英語に答えるほど、3Dの島で先へ進める</a:t>
-            </a:r>
-          </a:p>
-        </p:txBody>
-      </p:sp>
-      <p:pic>
-        <p:nvPicPr>
-          <p:cNvPr id="3" name="Picture 2" descr="screen-fw-catch.jpg"/>
-          <p:cNvPicPr>
-            <a:picLocks noChangeAspect="1"/>
-          </p:cNvPicPr>
-          <p:nvPr/>
-        </p:nvPicPr>
-        <p:blipFill>
-          <a:blip r:embed="rId2"/>
-          <a:stretch>
-            <a:fillRect/>
-          </a:stretch>
-        </p:blipFill>
-        <p:spPr>
-          <a:xfrm>
-            <a:off x="457200" y="1188720"/>
-            <a:ext cx="3611880" cy="2708910"/>
-          </a:xfrm>
-          <a:prstGeom prst="rect">
-            <a:avLst/>
-          </a:prstGeom>
-        </p:spPr>
-      </p:pic>
-      <p:sp>
-        <p:nvSpPr>
-          <p:cNvPr id="4" name="TextBox 3"/>
+              <a:t>授業だけでは解けない、教室の3つの課題</a:t>
+            </a:r>
+          </a:p>
+        </p:txBody>
+      </p:sp>
+      <p:sp>
+        <p:nvSpPr>
+          <p:cNvPr id="3" name="Rounded Rectangle 2"/>
+          <p:cNvSpPr/>
+          <p:nvPr/>
+        </p:nvSpPr>
+        <p:spPr>
+          <a:xfrm>
+            <a:off x="457200" y="1325880"/>
+            <a:ext cx="2606040" cy="3017520"/>
+          </a:xfrm>
+          <a:prstGeom prst="roundRect">
+            <a:avLst>
+              <a:gd name="adj" fmla="val 6000"/>
+            </a:avLst>
+          </a:prstGeom>
+          <a:solidFill>
+            <a:srgbClr val="EEF3EF"/>
+          </a:solidFill>
+          <a:ln>
+            <a:noFill/>
+          </a:ln>
+          <a:effectLst/>
+        </p:spPr>
+        <p:style>
+          <a:lnRef idx="1">
+            <a:schemeClr val="accent1"/>
+          </a:lnRef>
+          <a:fillRef idx="3">
+            <a:schemeClr val="accent1"/>
+          </a:fillRef>
+          <a:effectRef idx="2">
+            <a:schemeClr val="accent1"/>
+          </a:effectRef>
+          <a:fontRef idx="minor">
+            <a:schemeClr val="lt1"/>
+          </a:fontRef>
+        </p:style>
+        <p:txBody>
+          <a:bodyPr rtlCol="0" anchor="ctr"/>
+          <a:lstStyle/>
+          <a:p>
+            <a:pPr algn="ctr"/>
+          </a:p>
+        </p:txBody>
+      </p:sp>
+      <p:sp>
+        <p:nvSpPr>
+          <p:cNvPr id="4" name="Oval 3"/>
+          <p:cNvSpPr/>
+          <p:nvPr/>
+        </p:nvSpPr>
+        <p:spPr>
+          <a:xfrm>
+            <a:off x="685800" y="1554480"/>
+            <a:ext cx="457200" cy="457200"/>
+          </a:xfrm>
+          <a:prstGeom prst="ellipse">
+            <a:avLst/>
+          </a:prstGeom>
+          <a:solidFill>
+            <a:srgbClr val="E27A2D"/>
+          </a:solidFill>
+          <a:ln>
+            <a:noFill/>
+          </a:ln>
+          <a:effectLst/>
+        </p:spPr>
+        <p:style>
+          <a:lnRef idx="1">
+            <a:schemeClr val="accent1"/>
+          </a:lnRef>
+          <a:fillRef idx="3">
+            <a:schemeClr val="accent1"/>
+          </a:fillRef>
+          <a:effectRef idx="2">
+            <a:schemeClr val="accent1"/>
+          </a:effectRef>
+          <a:fontRef idx="minor">
+            <a:schemeClr val="lt1"/>
+          </a:fontRef>
+        </p:style>
+        <p:txBody>
+          <a:bodyPr rtlCol="0" anchor="ctr" lIns="0" rIns="0"/>
+          <a:lstStyle/>
+          <a:p>
+            <a:pPr algn="ctr"/>
+            <a:r>
+              <a:rPr sz="1800" b="1">
+                <a:solidFill>
+                  <a:srgbClr val="FFFFFF"/>
+                </a:solidFill>
+                <a:latin typeface="Noto Sans JP"/>
+              </a:rPr>
+              <a:t>1</a:t>
+            </a:r>
+          </a:p>
+        </p:txBody>
+      </p:sp>
+      <p:sp>
+        <p:nvSpPr>
+          <p:cNvPr id="5" name="TextBox 4"/>
           <p:cNvSpPr txBox="1"/>
           <p:nvPr/>
         </p:nvSpPr>
         <p:spPr>
           <a:xfrm>
-            <a:off x="457200" y="3959352"/>
-            <a:ext cx="3611880" cy="310896"/>
+            <a:off x="685800" y="2194560"/>
+            <a:ext cx="2194560" cy="731520"/>
           </a:xfrm>
           <a:prstGeom prst="rect">
             <a:avLst/>
@@ -3473,41 +3550,17 @@
           <a:p>
             <a:pPr algn="l"/>
             <a:r>
-              <a:rPr sz="1200" b="0">
-                <a:solidFill>
-                  <a:srgbClr val="66756B"/>
-                </a:solidFill>
-                <a:latin typeface="Noto Sans JP"/>
-              </a:rPr>
-              <a:t>つり島：英語に正解すると魚が釣れる</a:t>
-            </a:r>
-          </a:p>
-        </p:txBody>
-      </p:sp>
-      <p:pic>
-        <p:nvPicPr>
-          <p:cNvPr id="5" name="Picture 4" descr="ranking.jpg"/>
-          <p:cNvPicPr>
-            <a:picLocks noChangeAspect="1"/>
-          </p:cNvPicPr>
-          <p:nvPr/>
-        </p:nvPicPr>
-        <p:blipFill>
-          <a:blip r:embed="rId3"/>
-          <a:stretch>
-            <a:fillRect/>
-          </a:stretch>
-        </p:blipFill>
-        <p:spPr>
-          <a:xfrm>
-            <a:off x="4251960" y="1188720"/>
-            <a:ext cx="2078181" cy="2743200"/>
-          </a:xfrm>
-          <a:prstGeom prst="rect">
-            <a:avLst/>
-          </a:prstGeom>
-        </p:spPr>
-      </p:pic>
+              <a:rPr sz="1700" b="1">
+                <a:solidFill>
+                  <a:srgbClr val="1B3A2F"/>
+                </a:solidFill>
+                <a:latin typeface="Noto Sans JP"/>
+              </a:rPr>
+              <a:t>英語にふれる時間が足りない</a:t>
+            </a:r>
+          </a:p>
+        </p:txBody>
+      </p:sp>
       <p:sp>
         <p:nvSpPr>
           <p:cNvPr id="6" name="TextBox 5"/>
@@ -3516,8 +3569,8 @@
         </p:nvSpPr>
         <p:spPr>
           <a:xfrm>
-            <a:off x="4251960" y="3959352"/>
-            <a:ext cx="2194560" cy="310896"/>
+            <a:off x="685800" y="2926080"/>
+            <a:ext cx="2194560" cy="1280160"/>
           </a:xfrm>
           <a:prstGeom prst="rect">
             <a:avLst/>
@@ -3532,27 +3585,126 @@
           <a:p>
             <a:pPr algn="l"/>
             <a:r>
-              <a:rPr sz="1200" b="0">
-                <a:solidFill>
-                  <a:srgbClr val="66756B"/>
-                </a:solidFill>
-                <a:latin typeface="Noto Sans JP"/>
-              </a:rPr>
-              <a:t>クラスのランキング</a:t>
-            </a:r>
-          </a:p>
-        </p:txBody>
-      </p:sp>
-      <p:sp>
-        <p:nvSpPr>
-          <p:cNvPr id="7" name="TextBox 6"/>
+              <a:rPr sz="1400" b="0">
+                <a:solidFill>
+                  <a:srgbClr val="1F2A24"/>
+                </a:solidFill>
+                <a:latin typeface="Noto Sans JP"/>
+              </a:rPr>
+              <a:t>週1回の授業だけでは、次の授業までに忘れてしまう</a:t>
+            </a:r>
+          </a:p>
+        </p:txBody>
+      </p:sp>
+      <p:sp>
+        <p:nvSpPr>
+          <p:cNvPr id="7" name="Rounded Rectangle 6"/>
+          <p:cNvSpPr/>
+          <p:nvPr/>
+        </p:nvSpPr>
+        <p:spPr>
+          <a:xfrm>
+            <a:off x="3273552" y="1325880"/>
+            <a:ext cx="2606040" cy="3017520"/>
+          </a:xfrm>
+          <a:prstGeom prst="roundRect">
+            <a:avLst>
+              <a:gd name="adj" fmla="val 6000"/>
+            </a:avLst>
+          </a:prstGeom>
+          <a:solidFill>
+            <a:srgbClr val="EEF3EF"/>
+          </a:solidFill>
+          <a:ln>
+            <a:noFill/>
+          </a:ln>
+          <a:effectLst/>
+        </p:spPr>
+        <p:style>
+          <a:lnRef idx="1">
+            <a:schemeClr val="accent1"/>
+          </a:lnRef>
+          <a:fillRef idx="3">
+            <a:schemeClr val="accent1"/>
+          </a:fillRef>
+          <a:effectRef idx="2">
+            <a:schemeClr val="accent1"/>
+          </a:effectRef>
+          <a:fontRef idx="minor">
+            <a:schemeClr val="lt1"/>
+          </a:fontRef>
+        </p:style>
+        <p:txBody>
+          <a:bodyPr rtlCol="0" anchor="ctr"/>
+          <a:lstStyle/>
+          <a:p>
+            <a:pPr algn="ctr"/>
+          </a:p>
+        </p:txBody>
+      </p:sp>
+      <p:sp>
+        <p:nvSpPr>
+          <p:cNvPr id="8" name="Oval 7"/>
+          <p:cNvSpPr/>
+          <p:nvPr/>
+        </p:nvSpPr>
+        <p:spPr>
+          <a:xfrm>
+            <a:off x="3502152" y="1554480"/>
+            <a:ext cx="457200" cy="457200"/>
+          </a:xfrm>
+          <a:prstGeom prst="ellipse">
+            <a:avLst/>
+          </a:prstGeom>
+          <a:solidFill>
+            <a:srgbClr val="E27A2D"/>
+          </a:solidFill>
+          <a:ln>
+            <a:noFill/>
+          </a:ln>
+          <a:effectLst/>
+        </p:spPr>
+        <p:style>
+          <a:lnRef idx="1">
+            <a:schemeClr val="accent1"/>
+          </a:lnRef>
+          <a:fillRef idx="3">
+            <a:schemeClr val="accent1"/>
+          </a:fillRef>
+          <a:effectRef idx="2">
+            <a:schemeClr val="accent1"/>
+          </a:effectRef>
+          <a:fontRef idx="minor">
+            <a:schemeClr val="lt1"/>
+          </a:fontRef>
+        </p:style>
+        <p:txBody>
+          <a:bodyPr rtlCol="0" anchor="ctr" lIns="0" rIns="0"/>
+          <a:lstStyle/>
+          <a:p>
+            <a:pPr algn="ctr"/>
+            <a:r>
+              <a:rPr sz="1800" b="1">
+                <a:solidFill>
+                  <a:srgbClr val="FFFFFF"/>
+                </a:solidFill>
+                <a:latin typeface="Noto Sans JP"/>
+              </a:rPr>
+              <a:t>2</a:t>
+            </a:r>
+          </a:p>
+        </p:txBody>
+      </p:sp>
+      <p:sp>
+        <p:nvSpPr>
+          <p:cNvPr id="9" name="TextBox 8"/>
           <p:cNvSpPr txBox="1"/>
           <p:nvPr/>
         </p:nvSpPr>
         <p:spPr>
           <a:xfrm>
-            <a:off x="6629400" y="1234440"/>
-            <a:ext cx="2103120" cy="2926080"/>
+            <a:off x="3502152" y="2194560"/>
+            <a:ext cx="2194560" cy="731520"/>
           </a:xfrm>
           <a:prstGeom prst="rect">
             <a:avLst/>
@@ -3565,27 +3717,42 @@
           </a:bodyPr>
           <a:lstStyle/>
           <a:p>
-            <a:pPr algn="l">
-              <a:spcAft>
-                <a:spcPts val="600"/>
-              </a:spcAft>
-            </a:pPr>
-            <a:r>
-              <a:rPr sz="1400" b="1">
+            <a:pPr algn="l"/>
+            <a:r>
+              <a:rPr sz="1700" b="1">
                 <a:solidFill>
                   <a:srgbClr val="1B3A2F"/>
                 </a:solidFill>
                 <a:latin typeface="Noto Sans JP"/>
               </a:rPr>
-              <a:t>19の島</a:t>
-            </a:r>
-          </a:p>
-          <a:p>
-            <a:pPr algn="l">
-              <a:spcAft>
-                <a:spcPts val="600"/>
-              </a:spcAft>
-            </a:pPr>
+              <a:t>退会が毎月少しずつ出る</a:t>
+            </a:r>
+          </a:p>
+        </p:txBody>
+      </p:sp>
+      <p:sp>
+        <p:nvSpPr>
+          <p:cNvPr id="10" name="TextBox 9"/>
+          <p:cNvSpPr txBox="1"/>
+          <p:nvPr/>
+        </p:nvSpPr>
+        <p:spPr>
+          <a:xfrm>
+            <a:off x="3502152" y="2926080"/>
+            <a:ext cx="2194560" cy="1280160"/>
+          </a:xfrm>
+          <a:prstGeom prst="rect">
+            <a:avLst/>
+          </a:prstGeom>
+          <a:noFill/>
+        </p:spPr>
+        <p:txBody>
+          <a:bodyPr wrap="square" anchor="t" lIns="36576" rIns="36576" tIns="36576" bIns="36576">
+            <a:spAutoFit/>
+          </a:bodyPr>
+          <a:lstStyle/>
+          <a:p>
+            <a:pPr algn="l"/>
             <a:r>
               <a:rPr sz="1400" b="0">
                 <a:solidFill>
@@ -3593,31 +3760,168 @@
                 </a:solidFill>
                 <a:latin typeface="Noto Sans JP"/>
               </a:rPr>
-              <a:t>つり・ぼくじょう・レース・英検など</a:t>
-            </a:r>
-          </a:p>
-          <a:p>
-            <a:pPr algn="l">
-              <a:spcAft>
-                <a:spcPts val="600"/>
-              </a:spcAft>
-            </a:pPr>
-            <a:r>
-              <a:rPr sz="1400" b="1">
+              <a:t>継続率が月95%なら、30人の教室で毎月1〜2人が辞める¹</a:t>
+            </a:r>
+          </a:p>
+        </p:txBody>
+      </p:sp>
+      <p:sp>
+        <p:nvSpPr>
+          <p:cNvPr id="11" name="Rounded Rectangle 10"/>
+          <p:cNvSpPr/>
+          <p:nvPr/>
+        </p:nvSpPr>
+        <p:spPr>
+          <a:xfrm>
+            <a:off x="6089904" y="1325880"/>
+            <a:ext cx="2606040" cy="3017520"/>
+          </a:xfrm>
+          <a:prstGeom prst="roundRect">
+            <a:avLst>
+              <a:gd name="adj" fmla="val 6000"/>
+            </a:avLst>
+          </a:prstGeom>
+          <a:solidFill>
+            <a:srgbClr val="EEF3EF"/>
+          </a:solidFill>
+          <a:ln>
+            <a:noFill/>
+          </a:ln>
+          <a:effectLst/>
+        </p:spPr>
+        <p:style>
+          <a:lnRef idx="1">
+            <a:schemeClr val="accent1"/>
+          </a:lnRef>
+          <a:fillRef idx="3">
+            <a:schemeClr val="accent1"/>
+          </a:fillRef>
+          <a:effectRef idx="2">
+            <a:schemeClr val="accent1"/>
+          </a:effectRef>
+          <a:fontRef idx="minor">
+            <a:schemeClr val="lt1"/>
+          </a:fontRef>
+        </p:style>
+        <p:txBody>
+          <a:bodyPr rtlCol="0" anchor="ctr"/>
+          <a:lstStyle/>
+          <a:p>
+            <a:pPr algn="ctr"/>
+          </a:p>
+        </p:txBody>
+      </p:sp>
+      <p:sp>
+        <p:nvSpPr>
+          <p:cNvPr id="12" name="Oval 11"/>
+          <p:cNvSpPr/>
+          <p:nvPr/>
+        </p:nvSpPr>
+        <p:spPr>
+          <a:xfrm>
+            <a:off x="6318504" y="1554480"/>
+            <a:ext cx="457200" cy="457200"/>
+          </a:xfrm>
+          <a:prstGeom prst="ellipse">
+            <a:avLst/>
+          </a:prstGeom>
+          <a:solidFill>
+            <a:srgbClr val="E27A2D"/>
+          </a:solidFill>
+          <a:ln>
+            <a:noFill/>
+          </a:ln>
+          <a:effectLst/>
+        </p:spPr>
+        <p:style>
+          <a:lnRef idx="1">
+            <a:schemeClr val="accent1"/>
+          </a:lnRef>
+          <a:fillRef idx="3">
+            <a:schemeClr val="accent1"/>
+          </a:fillRef>
+          <a:effectRef idx="2">
+            <a:schemeClr val="accent1"/>
+          </a:effectRef>
+          <a:fontRef idx="minor">
+            <a:schemeClr val="lt1"/>
+          </a:fontRef>
+        </p:style>
+        <p:txBody>
+          <a:bodyPr rtlCol="0" anchor="ctr" lIns="0" rIns="0"/>
+          <a:lstStyle/>
+          <a:p>
+            <a:pPr algn="ctr"/>
+            <a:r>
+              <a:rPr sz="1800" b="1">
+                <a:solidFill>
+                  <a:srgbClr val="FFFFFF"/>
+                </a:solidFill>
+                <a:latin typeface="Noto Sans JP"/>
+              </a:rPr>
+              <a:t>3</a:t>
+            </a:r>
+          </a:p>
+        </p:txBody>
+      </p:sp>
+      <p:sp>
+        <p:nvSpPr>
+          <p:cNvPr id="13" name="TextBox 12"/>
+          <p:cNvSpPr txBox="1"/>
+          <p:nvPr/>
+        </p:nvSpPr>
+        <p:spPr>
+          <a:xfrm>
+            <a:off x="6318504" y="2194560"/>
+            <a:ext cx="2194560" cy="731520"/>
+          </a:xfrm>
+          <a:prstGeom prst="rect">
+            <a:avLst/>
+          </a:prstGeom>
+          <a:noFill/>
+        </p:spPr>
+        <p:txBody>
+          <a:bodyPr wrap="square" anchor="t" lIns="36576" rIns="36576" tIns="36576" bIns="36576">
+            <a:spAutoFit/>
+          </a:bodyPr>
+          <a:lstStyle/>
+          <a:p>
+            <a:pPr algn="l"/>
+            <a:r>
+              <a:rPr sz="1700" b="1">
                 <a:solidFill>
                   <a:srgbClr val="1B3A2F"/>
                 </a:solidFill>
                 <a:latin typeface="Noto Sans JP"/>
               </a:rPr>
-              <a:t>判定はサーバー</a:t>
-            </a:r>
-          </a:p>
-          <a:p>
-            <a:pPr algn="l">
-              <a:spcAft>
-                <a:spcPts val="600"/>
-              </a:spcAft>
-            </a:pPr>
+              <a:t>保護者に成果が見えにくい</a:t>
+            </a:r>
+          </a:p>
+        </p:txBody>
+      </p:sp>
+      <p:sp>
+        <p:nvSpPr>
+          <p:cNvPr id="14" name="TextBox 13"/>
+          <p:cNvSpPr txBox="1"/>
+          <p:nvPr/>
+        </p:nvSpPr>
+        <p:spPr>
+          <a:xfrm>
+            <a:off x="6318504" y="2926080"/>
+            <a:ext cx="2194560" cy="1280160"/>
+          </a:xfrm>
+          <a:prstGeom prst="rect">
+            <a:avLst/>
+          </a:prstGeom>
+          <a:noFill/>
+        </p:spPr>
+        <p:txBody>
+          <a:bodyPr wrap="square" anchor="t" lIns="36576" rIns="36576" tIns="36576" bIns="36576">
+            <a:spAutoFit/>
+          </a:bodyPr>
+          <a:lstStyle/>
+          <a:p>
+            <a:pPr algn="l"/>
             <a:r>
               <a:rPr sz="1400" b="0">
                 <a:solidFill>
@@ -3625,39 +3929,42 @@
                 </a:solidFill>
                 <a:latin typeface="Noto Sans JP"/>
               </a:rPr>
-              <a:t>正解とコインを画面側で変えられない</a:t>
-            </a:r>
-          </a:p>
-          <a:p>
-            <a:pPr algn="l">
-              <a:spcAft>
-                <a:spcPts val="600"/>
-              </a:spcAft>
-            </a:pPr>
-            <a:r>
-              <a:rPr sz="1400" b="1">
-                <a:solidFill>
-                  <a:srgbClr val="1B3A2F"/>
-                </a:solidFill>
-                <a:latin typeface="Noto Sans JP"/>
-              </a:rPr>
-              <a:t>21の指標で順位</a:t>
-            </a:r>
-          </a:p>
-          <a:p>
-            <a:pPr algn="l">
-              <a:spcAft>
-                <a:spcPts val="600"/>
-              </a:spcAft>
-            </a:pPr>
-            <a:r>
-              <a:rPr sz="1400" b="0">
-                <a:solidFill>
-                  <a:srgbClr val="1F2A24"/>
-                </a:solidFill>
-                <a:latin typeface="Noto Sans JP"/>
-              </a:rPr>
-              <a:t>今週のXP・正解数・学習時間など</a:t>
+              <a:t>「何ができるようになったか」を伝える手間が先生にかかる</a:t>
+            </a:r>
+          </a:p>
+        </p:txBody>
+      </p:sp>
+      <p:sp>
+        <p:nvSpPr>
+          <p:cNvPr id="15" name="TextBox 14"/>
+          <p:cNvSpPr txBox="1"/>
+          <p:nvPr/>
+        </p:nvSpPr>
+        <p:spPr>
+          <a:xfrm>
+            <a:off x="457200" y="4709160"/>
+            <a:ext cx="8229600" cy="274320"/>
+          </a:xfrm>
+          <a:prstGeom prst="rect">
+            <a:avLst/>
+          </a:prstGeom>
+          <a:noFill/>
+        </p:spPr>
+        <p:txBody>
+          <a:bodyPr wrap="square" anchor="t" lIns="36576" rIns="36576" tIns="36576" bIns="36576">
+            <a:spAutoFit/>
+          </a:bodyPr>
+          <a:lstStyle/>
+          <a:p>
+            <a:pPr algn="l"/>
+            <a:r>
+              <a:rPr sz="1000" b="0">
+                <a:solidFill>
+                  <a:srgbClr val="66756B"/>
+                </a:solidFill>
+                <a:latin typeface="Noto Sans JP"/>
+              </a:rPr>
+              <a:t>¹ 子ども英会話教室の継続率の平均は月93〜97%。出典：レスティック「英会話スクールの継続率の平均」</a:t>
             </a:r>
           </a:p>
         </p:txBody>
@@ -3718,69 +4025,67 @@
                 </a:solidFill>
                 <a:latin typeface="Noto Sans JP"/>
               </a:rPr>
-              <a:t>AIのウーピーと英会話・英検の面接を練習</a:t>
-            </a:r>
-          </a:p>
-        </p:txBody>
-      </p:sp>
-      <p:pic>
-        <p:nvPicPr>
-          <p:cNvPr id="3" name="Picture 2" descr="screen-convtalk.jpg"/>
-          <p:cNvPicPr>
-            <a:picLocks noChangeAspect="1"/>
-          </p:cNvPicPr>
-          <p:nvPr/>
-        </p:nvPicPr>
-        <p:blipFill>
-          <a:blip r:embed="rId2"/>
-          <a:stretch>
-            <a:fillRect/>
-          </a:stretch>
-        </p:blipFill>
-        <p:spPr>
-          <a:xfrm>
-            <a:off x="457200" y="1188720"/>
-            <a:ext cx="3977639" cy="2486024"/>
-          </a:xfrm>
-          <a:prstGeom prst="rect">
-            <a:avLst/>
-          </a:prstGeom>
-        </p:spPr>
-      </p:pic>
-      <p:pic>
-        <p:nvPicPr>
-          <p:cNvPr id="4" name="Picture 3" descr="screen-interview.jpg"/>
-          <p:cNvPicPr>
-            <a:picLocks noChangeAspect="1"/>
-          </p:cNvPicPr>
-          <p:nvPr/>
-        </p:nvPicPr>
-        <p:blipFill>
-          <a:blip r:embed="rId3"/>
-          <a:stretch>
-            <a:fillRect/>
-          </a:stretch>
-        </p:blipFill>
-        <p:spPr>
-          <a:xfrm>
-            <a:off x="4709160" y="1188720"/>
-            <a:ext cx="3977639" cy="2486024"/>
-          </a:xfrm>
-          <a:prstGeom prst="rect">
-            <a:avLst/>
-          </a:prstGeom>
-        </p:spPr>
-      </p:pic>
-      <p:sp>
-        <p:nvSpPr>
-          <p:cNvPr id="5" name="TextBox 4"/>
+              <a:t>子ども・先生・保護者を1つの記録でつなぐ</a:t>
+            </a:r>
+          </a:p>
+        </p:txBody>
+      </p:sp>
+      <p:sp>
+        <p:nvSpPr>
+          <p:cNvPr id="3" name="Rounded Rectangle 2"/>
+          <p:cNvSpPr/>
+          <p:nvPr/>
+        </p:nvSpPr>
+        <p:spPr>
+          <a:xfrm>
+            <a:off x="457200" y="1371600"/>
+            <a:ext cx="2468880" cy="2560320"/>
+          </a:xfrm>
+          <a:prstGeom prst="roundRect">
+            <a:avLst>
+              <a:gd name="adj" fmla="val 8000"/>
+            </a:avLst>
+          </a:prstGeom>
+          <a:solidFill>
+            <a:srgbClr val="EEF3EF"/>
+          </a:solidFill>
+          <a:ln>
+            <a:noFill/>
+          </a:ln>
+          <a:effectLst/>
+        </p:spPr>
+        <p:style>
+          <a:lnRef idx="1">
+            <a:schemeClr val="accent1"/>
+          </a:lnRef>
+          <a:fillRef idx="3">
+            <a:schemeClr val="accent1"/>
+          </a:fillRef>
+          <a:effectRef idx="2">
+            <a:schemeClr val="accent1"/>
+          </a:effectRef>
+          <a:fontRef idx="minor">
+            <a:schemeClr val="lt1"/>
+          </a:fontRef>
+        </p:style>
+        <p:txBody>
+          <a:bodyPr rtlCol="0" anchor="ctr"/>
+          <a:lstStyle/>
+          <a:p>
+            <a:pPr algn="ctr"/>
+          </a:p>
+        </p:txBody>
+      </p:sp>
+      <p:sp>
+        <p:nvSpPr>
+          <p:cNvPr id="4" name="TextBox 3"/>
           <p:cNvSpPr txBox="1"/>
           <p:nvPr/>
         </p:nvSpPr>
         <p:spPr>
           <a:xfrm>
-            <a:off x="457200" y="3767328"/>
-            <a:ext cx="3977639" cy="731520"/>
+            <a:off x="621792" y="1508760"/>
+            <a:ext cx="2139696" cy="2286000"/>
           </a:xfrm>
           <a:prstGeom prst="rect">
             <a:avLst/>
@@ -3795,32 +4100,23 @@
           <a:p>
             <a:pPr algn="l">
               <a:spcAft>
-                <a:spcPts val="200"/>
+                <a:spcPts val="300"/>
               </a:spcAft>
             </a:pPr>
             <a:r>
-              <a:rPr sz="1400" b="1">
+              <a:rPr sz="1600" b="1">
                 <a:solidFill>
                   <a:srgbClr val="1B3A2F"/>
                 </a:solidFill>
                 <a:latin typeface="Noto Sans JP"/>
               </a:rPr>
-              <a:t>英会話島</a:t>
-            </a:r>
-            <a:r>
-              <a:rPr sz="1400" b="0">
-                <a:solidFill>
-                  <a:srgbClr val="1F2A24"/>
-                </a:solidFill>
-                <a:latin typeface="Noto Sans JP"/>
-              </a:rPr>
-              <a:t>　カフェ・買い物など8つの場面</a:t>
+              <a:t>子ども</a:t>
             </a:r>
           </a:p>
           <a:p>
             <a:pPr algn="l">
               <a:spcAft>
-                <a:spcPts val="200"/>
+                <a:spcPts val="300"/>
               </a:spcAft>
             </a:pPr>
             <a:r>
@@ -3830,8 +4126,70 @@
                 </a:solidFill>
                 <a:latin typeface="Noto Sans JP"/>
               </a:rPr>
-              <a:t>言えたことをサーバーが判定してXPとコイン</a:t>
-            </a:r>
+              <a:t>島で英語に答え、AIと話す</a:t>
+            </a:r>
+          </a:p>
+          <a:p>
+            <a:pPr algn="l">
+              <a:spcAft>
+                <a:spcPts val="300"/>
+              </a:spcAft>
+            </a:pPr>
+            <a:r>
+              <a:rPr sz="1400" b="0">
+                <a:solidFill>
+                  <a:srgbClr val="1F2A24"/>
+                </a:solidFill>
+                <a:latin typeface="Noto Sans JP"/>
+              </a:rPr>
+              <a:t>家でも授業でも同じ世界</a:t>
+            </a:r>
+          </a:p>
+        </p:txBody>
+      </p:sp>
+      <p:sp>
+        <p:nvSpPr>
+          <p:cNvPr id="5" name="Rounded Rectangle 4"/>
+          <p:cNvSpPr/>
+          <p:nvPr/>
+        </p:nvSpPr>
+        <p:spPr>
+          <a:xfrm>
+            <a:off x="3337560" y="1371600"/>
+            <a:ext cx="2468880" cy="2560320"/>
+          </a:xfrm>
+          <a:prstGeom prst="roundRect">
+            <a:avLst>
+              <a:gd name="adj" fmla="val 8000"/>
+            </a:avLst>
+          </a:prstGeom>
+          <a:solidFill>
+            <a:srgbClr val="FFF1E3"/>
+          </a:solidFill>
+          <a:ln>
+            <a:noFill/>
+          </a:ln>
+          <a:effectLst/>
+        </p:spPr>
+        <p:style>
+          <a:lnRef idx="1">
+            <a:schemeClr val="accent1"/>
+          </a:lnRef>
+          <a:fillRef idx="3">
+            <a:schemeClr val="accent1"/>
+          </a:fillRef>
+          <a:effectRef idx="2">
+            <a:schemeClr val="accent1"/>
+          </a:effectRef>
+          <a:fontRef idx="minor">
+            <a:schemeClr val="lt1"/>
+          </a:fontRef>
+        </p:style>
+        <p:txBody>
+          <a:bodyPr rtlCol="0" anchor="ctr"/>
+          <a:lstStyle/>
+          <a:p>
+            <a:pPr algn="ctr"/>
           </a:p>
         </p:txBody>
       </p:sp>
@@ -3843,8 +4201,8 @@
         </p:nvSpPr>
         <p:spPr>
           <a:xfrm>
-            <a:off x="4709160" y="3767328"/>
-            <a:ext cx="3977639" cy="731520"/>
+            <a:off x="3502152" y="1508760"/>
+            <a:ext cx="2139696" cy="2286000"/>
           </a:xfrm>
           <a:prstGeom prst="rect">
             <a:avLst/>
@@ -3859,32 +4217,23 @@
           <a:p>
             <a:pPr algn="l">
               <a:spcAft>
-                <a:spcPts val="200"/>
+                <a:spcPts val="300"/>
               </a:spcAft>
             </a:pPr>
             <a:r>
-              <a:rPr sz="1400" b="1">
+              <a:rPr sz="1600" b="1">
                 <a:solidFill>
                   <a:srgbClr val="1B3A2F"/>
                 </a:solidFill>
                 <a:latin typeface="Noto Sans JP"/>
               </a:rPr>
-              <a:t>英検5〜3級の島</a:t>
-            </a:r>
-            <a:r>
-              <a:rPr sz="1400" b="0">
-                <a:solidFill>
-                  <a:srgbClr val="1F2A24"/>
-                </a:solidFill>
-                <a:latin typeface="Noto Sans JP"/>
-              </a:rPr>
-              <a:t>　読む・聞く・書く・話す</a:t>
+              <a:t>学習記録</a:t>
             </a:r>
           </a:p>
           <a:p>
             <a:pPr algn="l">
               <a:spcAft>
-                <a:spcPts val="200"/>
+                <a:spcPts val="300"/>
               </a:spcAft>
             </a:pPr>
             <a:r>
@@ -3894,21 +4243,83 @@
                 </a:solidFill>
                 <a:latin typeface="Noto Sans JP"/>
               </a:rPr>
-              <a:t>本番と同じ順番の面接練習。採点の厳しさは先生が選ぶ</a:t>
-            </a:r>
-          </a:p>
-        </p:txBody>
-      </p:sp>
-      <p:sp>
-        <p:nvSpPr>
-          <p:cNvPr id="7" name="TextBox 6"/>
+              <a:t>正解・コイン・時間をサーバーが判定して保存</a:t>
+            </a:r>
+          </a:p>
+          <a:p>
+            <a:pPr algn="l">
+              <a:spcAft>
+                <a:spcPts val="300"/>
+              </a:spcAft>
+            </a:pPr>
+            <a:r>
+              <a:rPr sz="1400" b="0">
+                <a:solidFill>
+                  <a:srgbClr val="1F2A24"/>
+                </a:solidFill>
+                <a:latin typeface="Noto Sans JP"/>
+              </a:rPr>
+              <a:t>画面側では変えられない</a:t>
+            </a:r>
+          </a:p>
+        </p:txBody>
+      </p:sp>
+      <p:sp>
+        <p:nvSpPr>
+          <p:cNvPr id="7" name="Rounded Rectangle 6"/>
+          <p:cNvSpPr/>
+          <p:nvPr/>
+        </p:nvSpPr>
+        <p:spPr>
+          <a:xfrm>
+            <a:off x="6217920" y="1234440"/>
+            <a:ext cx="2468880" cy="1325880"/>
+          </a:xfrm>
+          <a:prstGeom prst="roundRect">
+            <a:avLst>
+              <a:gd name="adj" fmla="val 8000"/>
+            </a:avLst>
+          </a:prstGeom>
+          <a:solidFill>
+            <a:srgbClr val="EEF3EF"/>
+          </a:solidFill>
+          <a:ln>
+            <a:noFill/>
+          </a:ln>
+          <a:effectLst/>
+        </p:spPr>
+        <p:style>
+          <a:lnRef idx="1">
+            <a:schemeClr val="accent1"/>
+          </a:lnRef>
+          <a:fillRef idx="3">
+            <a:schemeClr val="accent1"/>
+          </a:fillRef>
+          <a:effectRef idx="2">
+            <a:schemeClr val="accent1"/>
+          </a:effectRef>
+          <a:fontRef idx="minor">
+            <a:schemeClr val="lt1"/>
+          </a:fontRef>
+        </p:style>
+        <p:txBody>
+          <a:bodyPr rtlCol="0" anchor="ctr"/>
+          <a:lstStyle/>
+          <a:p>
+            <a:pPr algn="ctr"/>
+          </a:p>
+        </p:txBody>
+      </p:sp>
+      <p:sp>
+        <p:nvSpPr>
+          <p:cNvPr id="8" name="TextBox 7"/>
           <p:cNvSpPr txBox="1"/>
           <p:nvPr/>
         </p:nvSpPr>
         <p:spPr>
           <a:xfrm>
-            <a:off x="457200" y="4681728"/>
-            <a:ext cx="8229600" cy="274320"/>
+            <a:off x="6382512" y="1371600"/>
+            <a:ext cx="2139696" cy="1051560"/>
           </a:xfrm>
           <a:prstGeom prst="rect">
             <a:avLst/>
@@ -3921,15 +4332,279 @@
           </a:bodyPr>
           <a:lstStyle/>
           <a:p>
+            <a:pPr algn="l">
+              <a:spcAft>
+                <a:spcPts val="300"/>
+              </a:spcAft>
+            </a:pPr>
+            <a:r>
+              <a:rPr sz="1600" b="1">
+                <a:solidFill>
+                  <a:srgbClr val="1B3A2F"/>
+                </a:solidFill>
+                <a:latin typeface="Noto Sans JP"/>
+              </a:rPr>
+              <a:t>先生</a:t>
+            </a:r>
+          </a:p>
+          <a:p>
+            <a:pPr algn="l">
+              <a:spcAft>
+                <a:spcPts val="300"/>
+              </a:spcAft>
+            </a:pPr>
+            <a:r>
+              <a:rPr sz="1400" b="0">
+                <a:solidFill>
+                  <a:srgbClr val="1F2A24"/>
+                </a:solidFill>
+                <a:latin typeface="Noto Sans JP"/>
+              </a:rPr>
+              <a:t>授業モード・気づき・メモ</a:t>
+            </a:r>
+          </a:p>
+        </p:txBody>
+      </p:sp>
+      <p:sp>
+        <p:nvSpPr>
+          <p:cNvPr id="9" name="Rounded Rectangle 8"/>
+          <p:cNvSpPr/>
+          <p:nvPr/>
+        </p:nvSpPr>
+        <p:spPr>
+          <a:xfrm>
+            <a:off x="6217920" y="2743200"/>
+            <a:ext cx="2468880" cy="1325880"/>
+          </a:xfrm>
+          <a:prstGeom prst="roundRect">
+            <a:avLst>
+              <a:gd name="adj" fmla="val 8000"/>
+            </a:avLst>
+          </a:prstGeom>
+          <a:solidFill>
+            <a:srgbClr val="EEF3EF"/>
+          </a:solidFill>
+          <a:ln>
+            <a:noFill/>
+          </a:ln>
+          <a:effectLst/>
+        </p:spPr>
+        <p:style>
+          <a:lnRef idx="1">
+            <a:schemeClr val="accent1"/>
+          </a:lnRef>
+          <a:fillRef idx="3">
+            <a:schemeClr val="accent1"/>
+          </a:fillRef>
+          <a:effectRef idx="2">
+            <a:schemeClr val="accent1"/>
+          </a:effectRef>
+          <a:fontRef idx="minor">
+            <a:schemeClr val="lt1"/>
+          </a:fontRef>
+        </p:style>
+        <p:txBody>
+          <a:bodyPr rtlCol="0" anchor="ctr"/>
+          <a:lstStyle/>
+          <a:p>
+            <a:pPr algn="ctr"/>
+          </a:p>
+        </p:txBody>
+      </p:sp>
+      <p:sp>
+        <p:nvSpPr>
+          <p:cNvPr id="10" name="TextBox 9"/>
+          <p:cNvSpPr txBox="1"/>
+          <p:nvPr/>
+        </p:nvSpPr>
+        <p:spPr>
+          <a:xfrm>
+            <a:off x="6382512" y="2880360"/>
+            <a:ext cx="2139696" cy="1051560"/>
+          </a:xfrm>
+          <a:prstGeom prst="rect">
+            <a:avLst/>
+          </a:prstGeom>
+          <a:noFill/>
+        </p:spPr>
+        <p:txBody>
+          <a:bodyPr wrap="square" anchor="t" lIns="36576" rIns="36576" tIns="36576" bIns="36576">
+            <a:spAutoFit/>
+          </a:bodyPr>
+          <a:lstStyle/>
+          <a:p>
+            <a:pPr algn="l">
+              <a:spcAft>
+                <a:spcPts val="300"/>
+              </a:spcAft>
+            </a:pPr>
+            <a:r>
+              <a:rPr sz="1600" b="1">
+                <a:solidFill>
+                  <a:srgbClr val="1B3A2F"/>
+                </a:solidFill>
+                <a:latin typeface="Noto Sans JP"/>
+              </a:rPr>
+              <a:t>保護者</a:t>
+            </a:r>
+          </a:p>
+          <a:p>
+            <a:pPr algn="l">
+              <a:spcAft>
+                <a:spcPts val="300"/>
+              </a:spcAft>
+            </a:pPr>
+            <a:r>
+              <a:rPr sz="1400" b="0">
+                <a:solidFill>
+                  <a:srgbClr val="1F2A24"/>
+                </a:solidFill>
+                <a:latin typeface="Noto Sans JP"/>
+              </a:rPr>
+              <a:t>レポートとLINEで毎週届く</a:t>
+            </a:r>
+          </a:p>
+        </p:txBody>
+      </p:sp>
+      <p:cxnSp>
+        <p:nvCxnSpPr>
+          <p:cNvPr id="11" name="Connector 10"/>
+          <p:cNvCxnSpPr/>
+          <p:nvPr/>
+        </p:nvCxnSpPr>
+        <p:spPr>
+          <a:xfrm>
+            <a:off x="2926080" y="2651760"/>
+            <a:ext cx="411480" cy="0"/>
+          </a:xfrm>
+          <a:prstGeom prst="line">
+            <a:avLst/>
+          </a:prstGeom>
+          <a:ln w="25400">
+            <a:solidFill>
+              <a:srgbClr val="66756B"/>
+            </a:solidFill>
+            <a:tailEnd type="triangle"/>
+          </a:ln>
+        </p:spPr>
+        <p:style>
+          <a:lnRef idx="2">
+            <a:schemeClr val="accent1"/>
+          </a:lnRef>
+          <a:fillRef idx="0">
+            <a:schemeClr val="accent1"/>
+          </a:fillRef>
+          <a:effectRef idx="1">
+            <a:schemeClr val="accent1"/>
+          </a:effectRef>
+          <a:fontRef idx="minor">
+            <a:schemeClr val="tx1"/>
+          </a:fontRef>
+        </p:style>
+      </p:cxnSp>
+      <p:cxnSp>
+        <p:nvCxnSpPr>
+          <p:cNvPr id="12" name="Connector 11"/>
+          <p:cNvCxnSpPr/>
+          <p:nvPr/>
+        </p:nvCxnSpPr>
+        <p:spPr>
+          <a:xfrm flipV="1">
+            <a:off x="5806440" y="1892807"/>
+            <a:ext cx="411480" cy="393193"/>
+          </a:xfrm>
+          <a:prstGeom prst="line">
+            <a:avLst/>
+          </a:prstGeom>
+          <a:ln w="25400">
+            <a:solidFill>
+              <a:srgbClr val="66756B"/>
+            </a:solidFill>
+            <a:tailEnd type="triangle"/>
+          </a:ln>
+        </p:spPr>
+        <p:style>
+          <a:lnRef idx="2">
+            <a:schemeClr val="accent1"/>
+          </a:lnRef>
+          <a:fillRef idx="0">
+            <a:schemeClr val="accent1"/>
+          </a:fillRef>
+          <a:effectRef idx="1">
+            <a:schemeClr val="accent1"/>
+          </a:effectRef>
+          <a:fontRef idx="minor">
+            <a:schemeClr val="tx1"/>
+          </a:fontRef>
+        </p:style>
+      </p:cxnSp>
+      <p:cxnSp>
+        <p:nvCxnSpPr>
+          <p:cNvPr id="13" name="Connector 12"/>
+          <p:cNvCxnSpPr/>
+          <p:nvPr/>
+        </p:nvCxnSpPr>
+        <p:spPr>
+          <a:xfrm>
+            <a:off x="5806440" y="3017520"/>
+            <a:ext cx="411480" cy="384048"/>
+          </a:xfrm>
+          <a:prstGeom prst="line">
+            <a:avLst/>
+          </a:prstGeom>
+          <a:ln w="25400">
+            <a:solidFill>
+              <a:srgbClr val="66756B"/>
+            </a:solidFill>
+            <a:tailEnd type="triangle"/>
+          </a:ln>
+        </p:spPr>
+        <p:style>
+          <a:lnRef idx="2">
+            <a:schemeClr val="accent1"/>
+          </a:lnRef>
+          <a:fillRef idx="0">
+            <a:schemeClr val="accent1"/>
+          </a:fillRef>
+          <a:effectRef idx="1">
+            <a:schemeClr val="accent1"/>
+          </a:effectRef>
+          <a:fontRef idx="minor">
+            <a:schemeClr val="tx1"/>
+          </a:fontRef>
+        </p:style>
+      </p:cxnSp>
+      <p:sp>
+        <p:nvSpPr>
+          <p:cNvPr id="14" name="TextBox 13"/>
+          <p:cNvSpPr txBox="1"/>
+          <p:nvPr/>
+        </p:nvSpPr>
+        <p:spPr>
+          <a:xfrm>
+            <a:off x="457200" y="4160520"/>
+            <a:ext cx="8229600" cy="457200"/>
+          </a:xfrm>
+          <a:prstGeom prst="rect">
+            <a:avLst/>
+          </a:prstGeom>
+          <a:noFill/>
+        </p:spPr>
+        <p:txBody>
+          <a:bodyPr wrap="square" anchor="t" lIns="36576" rIns="36576" tIns="36576" bIns="36576">
+            <a:spAutoFit/>
+          </a:bodyPr>
+          <a:lstStyle/>
+          <a:p>
             <a:pPr algn="l"/>
             <a:r>
-              <a:rPr sz="1100" b="0">
-                <a:solidFill>
-                  <a:srgbClr val="66756B"/>
-                </a:solidFill>
-                <a:latin typeface="Noto Sans JP"/>
-              </a:rPr>
-              <a:t>AI英会話・英検の島・みんなで話す島はプレミアム機能（名簿で生徒ごとにオン）</a:t>
+              <a:rPr sz="1400" b="0">
+                <a:solidFill>
+                  <a:srgbClr val="1F2A24"/>
+                </a:solidFill>
+                <a:latin typeface="Noto Sans JP"/>
+              </a:rPr>
+              <a:t>1つの記録から授業・家庭・保護者連絡が動くので、数字を集め直す作業はありません。</a:t>
             </a:r>
           </a:p>
         </p:txBody>
@@ -3990,14 +4665,14 @@
                 </a:solidFill>
                 <a:latin typeface="Noto Sans JP"/>
               </a:rPr>
-              <a:t>授業モードでクラス全員をワンタップで動かす</a:t>
+              <a:t>家でも続く：英語に答えるほど島で先へ進めるゲーム</a:t>
             </a:r>
           </a:p>
         </p:txBody>
       </p:sp>
       <p:pic>
         <p:nvPicPr>
-          <p:cNvPr id="3" name="Picture 2" descr="screen-classmode.jpg"/>
+          <p:cNvPr id="3" name="Picture 2" descr="screen-fw-catch.jpg"/>
           <p:cNvPicPr>
             <a:picLocks noChangeAspect="1"/>
           </p:cNvPicPr>
@@ -4012,16 +4687,51 @@
         <p:spPr>
           <a:xfrm>
             <a:off x="457200" y="1188720"/>
-            <a:ext cx="3977639" cy="2486024"/>
+            <a:ext cx="3017520" cy="2263140"/>
           </a:xfrm>
           <a:prstGeom prst="rect">
             <a:avLst/>
           </a:prstGeom>
         </p:spPr>
       </p:pic>
+      <p:sp>
+        <p:nvSpPr>
+          <p:cNvPr id="4" name="TextBox 3"/>
+          <p:cNvSpPr txBox="1"/>
+          <p:nvPr/>
+        </p:nvSpPr>
+        <p:spPr>
+          <a:xfrm>
+            <a:off x="457200" y="3502152"/>
+            <a:ext cx="3017520" cy="310896"/>
+          </a:xfrm>
+          <a:prstGeom prst="rect">
+            <a:avLst/>
+          </a:prstGeom>
+          <a:noFill/>
+        </p:spPr>
+        <p:txBody>
+          <a:bodyPr wrap="square" anchor="t" lIns="36576" rIns="36576" tIns="36576" bIns="36576">
+            <a:spAutoFit/>
+          </a:bodyPr>
+          <a:lstStyle/>
+          <a:p>
+            <a:pPr algn="l"/>
+            <a:r>
+              <a:rPr sz="1200" b="0">
+                <a:solidFill>
+                  <a:srgbClr val="66756B"/>
+                </a:solidFill>
+                <a:latin typeface="Noto Sans JP"/>
+              </a:rPr>
+              <a:t>つり島：正解すると魚が釣れる</a:t>
+            </a:r>
+          </a:p>
+        </p:txBody>
+      </p:sp>
       <p:pic>
         <p:nvPicPr>
-          <p:cNvPr id="4" name="Picture 3" descr="screen-teacher.jpg"/>
+          <p:cNvPr id="5" name="Picture 4" descr="screen-convtalk.jpg"/>
           <p:cNvPicPr>
             <a:picLocks noChangeAspect="1"/>
           </p:cNvPicPr>
@@ -4035,8 +4745,8 @@
         </p:blipFill>
         <p:spPr>
           <a:xfrm>
-            <a:off x="4709160" y="1188720"/>
-            <a:ext cx="3977639" cy="2486024"/>
+            <a:off x="3657600" y="1188720"/>
+            <a:ext cx="3017520" cy="1885949"/>
           </a:xfrm>
           <a:prstGeom prst="rect">
             <a:avLst/>
@@ -4045,14 +4755,14 @@
       </p:pic>
       <p:sp>
         <p:nvSpPr>
-          <p:cNvPr id="5" name="TextBox 4"/>
+          <p:cNvPr id="6" name="TextBox 5"/>
           <p:cNvSpPr txBox="1"/>
           <p:nvPr/>
         </p:nvSpPr>
         <p:spPr>
           <a:xfrm>
-            <a:off x="457200" y="3767328"/>
-            <a:ext cx="3977639" cy="822960"/>
+            <a:off x="3657600" y="3108960"/>
+            <a:ext cx="3017520" cy="310896"/>
           </a:xfrm>
           <a:prstGeom prst="rect">
             <a:avLst/>
@@ -4065,49 +4775,29 @@
           </a:bodyPr>
           <a:lstStyle/>
           <a:p>
-            <a:pPr algn="l">
-              <a:spcAft>
-                <a:spcPts val="200"/>
-              </a:spcAft>
-            </a:pPr>
-            <a:r>
-              <a:rPr sz="1400" b="1">
-                <a:solidFill>
-                  <a:srgbClr val="1B3A2F"/>
-                </a:solidFill>
-                <a:latin typeface="Noto Sans JP"/>
-              </a:rPr>
-              <a:t>授業モード</a:t>
-            </a:r>
-          </a:p>
-          <a:p>
-            <a:pPr algn="l">
-              <a:spcAft>
-                <a:spcPts val="200"/>
-              </a:spcAft>
-            </a:pPr>
-            <a:r>
-              <a:rPr sz="1400" b="0">
-                <a:solidFill>
-                  <a:srgbClr val="1F2A24"/>
-                </a:solidFill>
-                <a:latin typeface="Noto Sans JP"/>
-              </a:rPr>
-              <a:t>集合・一時停止・苦手単語の復習・みんなで移動</a:t>
-            </a:r>
-          </a:p>
-        </p:txBody>
-      </p:sp>
-      <p:sp>
-        <p:nvSpPr>
-          <p:cNvPr id="6" name="TextBox 5"/>
+            <a:pPr algn="l"/>
+            <a:r>
+              <a:rPr sz="1200" b="0">
+                <a:solidFill>
+                  <a:srgbClr val="66756B"/>
+                </a:solidFill>
+                <a:latin typeface="Noto Sans JP"/>
+              </a:rPr>
+              <a:t>英会話島：AIのウーピーと会話</a:t>
+            </a:r>
+          </a:p>
+        </p:txBody>
+      </p:sp>
+      <p:sp>
+        <p:nvSpPr>
+          <p:cNvPr id="7" name="TextBox 6"/>
           <p:cNvSpPr txBox="1"/>
           <p:nvPr/>
         </p:nvSpPr>
         <p:spPr>
           <a:xfrm>
-            <a:off x="4709160" y="3767328"/>
-            <a:ext cx="3977639" cy="822960"/>
+            <a:off x="6858000" y="1234440"/>
+            <a:ext cx="1828800" cy="3200400"/>
           </a:xfrm>
           <a:prstGeom prst="rect">
             <a:avLst/>
@@ -4122,7 +4812,7 @@
           <a:p>
             <a:pPr algn="l">
               <a:spcAft>
-                <a:spcPts val="200"/>
+                <a:spcPts val="500"/>
               </a:spcAft>
             </a:pPr>
             <a:r>
@@ -4132,13 +4822,13 @@
                 </a:solidFill>
                 <a:latin typeface="Noto Sans JP"/>
               </a:rPr>
-              <a:t>先生コンソール</a:t>
+              <a:t>19の島</a:t>
             </a:r>
           </a:p>
           <a:p>
             <a:pPr algn="l">
               <a:spcAft>
-                <a:spcPts val="200"/>
+                <a:spcPts val="500"/>
               </a:spcAft>
             </a:pPr>
             <a:r>
@@ -4148,7 +4838,106 @@
                 </a:solidFill>
                 <a:latin typeface="Noto Sans JP"/>
               </a:rPr>
-              <a:t>声をかける子の気づき・先生のメモ・英検準会場の見込み</a:t>
+              <a:t>つり・牧場・レース・英検など</a:t>
+            </a:r>
+          </a:p>
+          <a:p>
+            <a:pPr algn="l">
+              <a:spcAft>
+                <a:spcPts val="500"/>
+              </a:spcAft>
+            </a:pPr>
+            <a:r>
+              <a:rPr sz="1400" b="1">
+                <a:solidFill>
+                  <a:srgbClr val="1B3A2F"/>
+                </a:solidFill>
+                <a:latin typeface="Noto Sans JP"/>
+              </a:rPr>
+              <a:t>AI英会話</a:t>
+            </a:r>
+          </a:p>
+          <a:p>
+            <a:pPr algn="l">
+              <a:spcAft>
+                <a:spcPts val="500"/>
+              </a:spcAft>
+            </a:pPr>
+            <a:r>
+              <a:rPr sz="1400" b="0">
+                <a:solidFill>
+                  <a:srgbClr val="1F2A24"/>
+                </a:solidFill>
+                <a:latin typeface="Noto Sans JP"/>
+              </a:rPr>
+              <a:t>8つの場面と英検の面接</a:t>
+            </a:r>
+          </a:p>
+          <a:p>
+            <a:pPr algn="l">
+              <a:spcAft>
+                <a:spcPts val="500"/>
+              </a:spcAft>
+            </a:pPr>
+            <a:r>
+              <a:rPr sz="1400" b="1">
+                <a:solidFill>
+                  <a:srgbClr val="1B3A2F"/>
+                </a:solidFill>
+                <a:latin typeface="Noto Sans JP"/>
+              </a:rPr>
+              <a:t>ランキング</a:t>
+            </a:r>
+          </a:p>
+          <a:p>
+            <a:pPr algn="l">
+              <a:spcAft>
+                <a:spcPts val="500"/>
+              </a:spcAft>
+            </a:pPr>
+            <a:r>
+              <a:rPr sz="1400" b="0">
+                <a:solidFill>
+                  <a:srgbClr val="1F2A24"/>
+                </a:solidFill>
+                <a:latin typeface="Noto Sans JP"/>
+              </a:rPr>
+              <a:t>21の指標でクラス内順位</a:t>
+            </a:r>
+          </a:p>
+        </p:txBody>
+      </p:sp>
+      <p:sp>
+        <p:nvSpPr>
+          <p:cNvPr id="8" name="TextBox 7"/>
+          <p:cNvSpPr txBox="1"/>
+          <p:nvPr/>
+        </p:nvSpPr>
+        <p:spPr>
+          <a:xfrm>
+            <a:off x="457200" y="3931920"/>
+            <a:ext cx="6217920" cy="640080"/>
+          </a:xfrm>
+          <a:prstGeom prst="rect">
+            <a:avLst/>
+          </a:prstGeom>
+          <a:noFill/>
+        </p:spPr>
+        <p:txBody>
+          <a:bodyPr wrap="square" anchor="t" lIns="36576" rIns="36576" tIns="36576" bIns="36576">
+            <a:spAutoFit/>
+          </a:bodyPr>
+          <a:lstStyle/>
+          <a:p>
+            <a:pPr algn="l"/>
+            <a:r>
+              <a:rPr sz="1400" b="0">
+                <a:solidFill>
+                  <a:srgbClr val="1F2A24"/>
+                </a:solidFill>
+                <a:latin typeface="Noto Sans JP"/>
+              </a:rPr>
+              <a:t>遊ぶ目的（魚・コイン・順位）が、英語を使う回数をそのまま増やす作りです。</a:t>
             </a:r>
           </a:p>
         </p:txBody>
@@ -4209,14 +4998,14 @@
                 </a:solidFill>
                 <a:latin typeface="Noto Sans JP"/>
               </a:rPr>
-              <a:t>保護者レポートは遊んだ記録から自動でできる</a:t>
+              <a:t>先生の手間を増やさず、クラス全員を動かせる</a:t>
             </a:r>
           </a:p>
         </p:txBody>
       </p:sp>
       <p:pic>
         <p:nvPicPr>
-          <p:cNvPr id="3" name="Picture 2" descr="infra-report.jpg"/>
+          <p:cNvPr id="3" name="Picture 2" descr="screen-classmode.jpg"/>
           <p:cNvPicPr>
             <a:picLocks noChangeAspect="1"/>
           </p:cNvPicPr>
@@ -4230,8 +5019,8 @@
         </p:blipFill>
         <p:spPr>
           <a:xfrm>
-            <a:off x="457200" y="1143000"/>
-            <a:ext cx="2346468" cy="3383280"/>
+            <a:off x="457200" y="1188720"/>
+            <a:ext cx="3977639" cy="2486024"/>
           </a:xfrm>
           <a:prstGeom prst="rect">
             <a:avLst/>
@@ -4240,7 +5029,7 @@
       </p:pic>
       <p:pic>
         <p:nvPicPr>
-          <p:cNvPr id="4" name="Picture 3" descr="report-page1.jpg"/>
+          <p:cNvPr id="4" name="Picture 3" descr="screen-teacher.jpg"/>
           <p:cNvPicPr>
             <a:picLocks noChangeAspect="1"/>
           </p:cNvPicPr>
@@ -4254,8 +5043,8 @@
         </p:blipFill>
         <p:spPr>
           <a:xfrm>
-            <a:off x="3017520" y="1143000"/>
-            <a:ext cx="2393477" cy="3383280"/>
+            <a:off x="4709160" y="1188720"/>
+            <a:ext cx="3977639" cy="2486024"/>
           </a:xfrm>
           <a:prstGeom prst="rect">
             <a:avLst/>
@@ -4270,8 +5059,8 @@
         </p:nvSpPr>
         <p:spPr>
           <a:xfrm>
-            <a:off x="457200" y="4572000"/>
-            <a:ext cx="5303520" cy="310896"/>
+            <a:off x="457200" y="3767328"/>
+            <a:ext cx="3977639" cy="822960"/>
           </a:xfrm>
           <a:prstGeom prst="rect">
             <a:avLst/>
@@ -4284,15 +5073,35 @@
           </a:bodyPr>
           <a:lstStyle/>
           <a:p>
-            <a:pPr algn="l"/>
-            <a:r>
-              <a:rPr sz="1200" b="0">
-                <a:solidFill>
-                  <a:srgbClr val="66756B"/>
-                </a:solidFill>
-                <a:latin typeface="Noto Sans JP"/>
-              </a:rPr>
-              <a:t>Webのレポート（左）とA4のPDF（右）</a:t>
+            <a:pPr algn="l">
+              <a:spcAft>
+                <a:spcPts val="200"/>
+              </a:spcAft>
+            </a:pPr>
+            <a:r>
+              <a:rPr sz="1400" b="1">
+                <a:solidFill>
+                  <a:srgbClr val="1B3A2F"/>
+                </a:solidFill>
+                <a:latin typeface="Noto Sans JP"/>
+              </a:rPr>
+              <a:t>授業モード</a:t>
+            </a:r>
+          </a:p>
+          <a:p>
+            <a:pPr algn="l">
+              <a:spcAft>
+                <a:spcPts val="200"/>
+              </a:spcAft>
+            </a:pPr>
+            <a:r>
+              <a:rPr sz="1400" b="0">
+                <a:solidFill>
+                  <a:srgbClr val="1F2A24"/>
+                </a:solidFill>
+                <a:latin typeface="Noto Sans JP"/>
+              </a:rPr>
+              <a:t>集合・一時停止・苦手単語の復習・みんなで移動をワンタップ</a:t>
             </a:r>
           </a:p>
         </p:txBody>
@@ -4305,8 +5114,8 @@
         </p:nvSpPr>
         <p:spPr>
           <a:xfrm>
-            <a:off x="5989320" y="1234440"/>
-            <a:ext cx="2697480" cy="3474720"/>
+            <a:off x="4709160" y="3767328"/>
+            <a:ext cx="3977639" cy="822960"/>
           </a:xfrm>
           <a:prstGeom prst="rect">
             <a:avLst/>
@@ -4321,129 +5130,33 @@
           <a:p>
             <a:pPr algn="l">
               <a:spcAft>
-                <a:spcPts val="400"/>
+                <a:spcPts val="200"/>
               </a:spcAft>
             </a:pPr>
             <a:r>
-              <a:rPr sz="1300" b="1">
+              <a:rPr sz="1400" b="1">
                 <a:solidFill>
                   <a:srgbClr val="1B3A2F"/>
                 </a:solidFill>
                 <a:latin typeface="Noto Sans JP"/>
               </a:rPr>
-              <a:t>今月のまとめ</a:t>
+              <a:t>先生コンソール</a:t>
             </a:r>
           </a:p>
           <a:p>
             <a:pPr algn="l">
               <a:spcAft>
-                <a:spcPts val="400"/>
+                <a:spcPts val="200"/>
               </a:spcAft>
             </a:pPr>
             <a:r>
-              <a:rPr sz="1300" b="0">
+              <a:rPr sz="1400" b="0">
                 <a:solidFill>
                   <a:srgbClr val="1F2A24"/>
                 </a:solidFill>
                 <a:latin typeface="Noto Sans JP"/>
               </a:rPr>
-              <a:t>来た日・問題数・正解率・学習時間、去年の同じ月とも比べる</a:t>
-            </a:r>
-          </a:p>
-          <a:p>
-            <a:pPr algn="l">
-              <a:spcAft>
-                <a:spcPts val="400"/>
-              </a:spcAft>
-            </a:pPr>
-            <a:r>
-              <a:rPr sz="1300" b="1">
-                <a:solidFill>
-                  <a:srgbClr val="1B3A2F"/>
-                </a:solidFill>
-                <a:latin typeface="Noto Sans JP"/>
-              </a:rPr>
-              <a:t>英検の目安と4技能</a:t>
-            </a:r>
-          </a:p>
-          <a:p>
-            <a:pPr algn="l">
-              <a:spcAft>
-                <a:spcPts val="400"/>
-              </a:spcAft>
-            </a:pPr>
-            <a:r>
-              <a:rPr sz="1300" b="0">
-                <a:solidFill>
-                  <a:srgbClr val="1F2A24"/>
-                </a:solidFill>
-                <a:latin typeface="Noto Sans JP"/>
-              </a:rPr>
-              <a:t>練習で目安に届いた級がわかる</a:t>
-            </a:r>
-          </a:p>
-          <a:p>
-            <a:pPr algn="l">
-              <a:spcAft>
-                <a:spcPts val="400"/>
-              </a:spcAft>
-            </a:pPr>
-            <a:r>
-              <a:rPr sz="1300" b="1">
-                <a:solidFill>
-                  <a:srgbClr val="1B3A2F"/>
-                </a:solidFill>
-                <a:latin typeface="Noto Sans JP"/>
-              </a:rPr>
-              <a:t>クラスの中の順位</a:t>
-            </a:r>
-          </a:p>
-          <a:p>
-            <a:pPr algn="l">
-              <a:spcAft>
-                <a:spcPts val="400"/>
-              </a:spcAft>
-            </a:pPr>
-            <a:r>
-              <a:rPr sz="1300" b="0">
-                <a:solidFill>
-                  <a:srgbClr val="1F2A24"/>
-                </a:solidFill>
-                <a:latin typeface="Noto Sans JP"/>
-              </a:rPr>
-              <a:t>本人の順位と人数だけを表示</a:t>
-            </a:r>
-          </a:p>
-          <a:p>
-            <a:pPr algn="l">
-              <a:spcAft>
-                <a:spcPts val="400"/>
-              </a:spcAft>
-            </a:pPr>
-            <a:r>
-              <a:rPr sz="1300" b="1">
-                <a:solidFill>
-                  <a:srgbClr val="1B3A2F"/>
-                </a:solidFill>
-                <a:latin typeface="Noto Sans JP"/>
-              </a:rPr>
-              <a:t>先生のメモ・記録証</a:t>
-            </a:r>
-          </a:p>
-          <a:p>
-            <a:pPr algn="l">
-              <a:spcAft>
-                <a:spcPts val="400"/>
-              </a:spcAft>
-            </a:pPr>
-            <a:r>
-              <a:rPr sz="1300" b="0">
-                <a:solidFill>
-                  <a:srgbClr val="1F2A24"/>
-                </a:solidFill>
-                <a:latin typeface="Noto Sans JP"/>
-              </a:rPr>
-              <a:t>面談メモもワンクリック</a:t>
+              <a:t>声をかけたい子の気づき・メモ・英検準会場の見込み</a:t>
             </a:r>
           </a:p>
         </p:txBody>
@@ -4504,14 +5217,14 @@
                 </a:solidFill>
                 <a:latin typeface="Noto Sans JP"/>
               </a:rPr>
-              <a:t>LINEで毎週自動配信、保護者はQRを読むだけ</a:t>
+              <a:t>保護者には毎週LINEでレポートが届く</a:t>
             </a:r>
           </a:p>
         </p:txBody>
       </p:sp>
       <p:pic>
         <p:nvPicPr>
-          <p:cNvPr id="3" name="Picture 2" descr="line-weekly.jpg"/>
+          <p:cNvPr id="3" name="Picture 2" descr="infra-report.jpg"/>
           <p:cNvPicPr>
             <a:picLocks noChangeAspect="1"/>
           </p:cNvPicPr>
@@ -4526,22 +5239,293 @@
         <p:spPr>
           <a:xfrm>
             <a:off x="457200" y="1143000"/>
-            <a:ext cx="2889504" cy="3611880"/>
+            <a:ext cx="2346468" cy="3383280"/>
           </a:xfrm>
           <a:prstGeom prst="rect">
             <a:avLst/>
           </a:prstGeom>
         </p:spPr>
       </p:pic>
-      <p:sp>
-        <p:nvSpPr>
-          <p:cNvPr id="4" name="Oval 3"/>
+      <p:pic>
+        <p:nvPicPr>
+          <p:cNvPr id="4" name="Picture 3" descr="line-weekly.jpg"/>
+          <p:cNvPicPr>
+            <a:picLocks noChangeAspect="1"/>
+          </p:cNvPicPr>
+          <p:nvPr/>
+        </p:nvPicPr>
+        <p:blipFill>
+          <a:blip r:embed="rId3"/>
+          <a:stretch>
+            <a:fillRect/>
+          </a:stretch>
+        </p:blipFill>
+        <p:spPr>
+          <a:xfrm>
+            <a:off x="2926080" y="1143000"/>
+            <a:ext cx="2706624" cy="3383280"/>
+          </a:xfrm>
+          <a:prstGeom prst="rect">
+            <a:avLst/>
+          </a:prstGeom>
+        </p:spPr>
+      </p:pic>
+      <p:sp>
+        <p:nvSpPr>
+          <p:cNvPr id="5" name="TextBox 4"/>
+          <p:cNvSpPr txBox="1"/>
+          <p:nvPr/>
+        </p:nvSpPr>
+        <p:spPr>
+          <a:xfrm>
+            <a:off x="457200" y="4572000"/>
+            <a:ext cx="5303520" cy="310896"/>
+          </a:xfrm>
+          <a:prstGeom prst="rect">
+            <a:avLst/>
+          </a:prstGeom>
+          <a:noFill/>
+        </p:spPr>
+        <p:txBody>
+          <a:bodyPr wrap="square" anchor="t" lIns="36576" rIns="36576" tIns="36576" bIns="36576">
+            <a:spAutoFit/>
+          </a:bodyPr>
+          <a:lstStyle/>
+          <a:p>
+            <a:pPr algn="l"/>
+            <a:r>
+              <a:rPr sz="1200" b="0">
+                <a:solidFill>
+                  <a:srgbClr val="66756B"/>
+                </a:solidFill>
+                <a:latin typeface="Noto Sans JP"/>
+              </a:rPr>
+              <a:t>Webのレポート（左）とLINEで届く週のレポート（右）</a:t>
+            </a:r>
+          </a:p>
+        </p:txBody>
+      </p:sp>
+      <p:sp>
+        <p:nvSpPr>
+          <p:cNvPr id="6" name="TextBox 5"/>
+          <p:cNvSpPr txBox="1"/>
+          <p:nvPr/>
+        </p:nvSpPr>
+        <p:spPr>
+          <a:xfrm>
+            <a:off x="5852160" y="1234440"/>
+            <a:ext cx="2834640" cy="3291840"/>
+          </a:xfrm>
+          <a:prstGeom prst="rect">
+            <a:avLst/>
+          </a:prstGeom>
+          <a:noFill/>
+        </p:spPr>
+        <p:txBody>
+          <a:bodyPr wrap="square" anchor="t" lIns="36576" rIns="36576" tIns="36576" bIns="36576">
+            <a:spAutoFit/>
+          </a:bodyPr>
+          <a:lstStyle/>
+          <a:p>
+            <a:pPr algn="l">
+              <a:spcAft>
+                <a:spcPts val="400"/>
+              </a:spcAft>
+            </a:pPr>
+            <a:r>
+              <a:rPr sz="1300" b="1">
+                <a:solidFill>
+                  <a:srgbClr val="1B3A2F"/>
+                </a:solidFill>
+                <a:latin typeface="Noto Sans JP"/>
+              </a:rPr>
+              <a:t>作るのは自動</a:t>
+            </a:r>
+          </a:p>
+          <a:p>
+            <a:pPr algn="l">
+              <a:spcAft>
+                <a:spcPts val="400"/>
+              </a:spcAft>
+            </a:pPr>
+            <a:r>
+              <a:rPr sz="1300" b="0">
+                <a:solidFill>
+                  <a:srgbClr val="1F2A24"/>
+                </a:solidFill>
+                <a:latin typeface="Noto Sans JP"/>
+              </a:rPr>
+              <a:t>英語をした日・答えた数・覚えた単語・来週のめあて</a:t>
+            </a:r>
+          </a:p>
+          <a:p>
+            <a:pPr algn="l">
+              <a:spcAft>
+                <a:spcPts val="400"/>
+              </a:spcAft>
+            </a:pPr>
+            <a:r>
+              <a:rPr sz="1300" b="1">
+                <a:solidFill>
+                  <a:srgbClr val="1B3A2F"/>
+                </a:solidFill>
+                <a:latin typeface="Noto Sans JP"/>
+              </a:rPr>
+              <a:t>登録はQRだけ</a:t>
+            </a:r>
+          </a:p>
+          <a:p>
+            <a:pPr algn="l">
+              <a:spcAft>
+                <a:spcPts val="400"/>
+              </a:spcAft>
+            </a:pPr>
+            <a:r>
+              <a:rPr sz="1300" b="0">
+                <a:solidFill>
+                  <a:srgbClr val="1F2A24"/>
+                </a:solidFill>
+                <a:latin typeface="Noto Sans JP"/>
+              </a:rPr>
+              <a:t>子どもごとのカードを読み取りLINEで受け取る</a:t>
+            </a:r>
+          </a:p>
+          <a:p>
+            <a:pPr algn="l">
+              <a:spcAft>
+                <a:spcPts val="400"/>
+              </a:spcAft>
+            </a:pPr>
+            <a:r>
+              <a:rPr sz="1300" b="1">
+                <a:solidFill>
+                  <a:srgbClr val="1B3A2F"/>
+                </a:solidFill>
+                <a:latin typeface="Noto Sans JP"/>
+              </a:rPr>
+              <a:t>先生のひとこと</a:t>
+            </a:r>
+          </a:p>
+          <a:p>
+            <a:pPr algn="l">
+              <a:spcAft>
+                <a:spcPts val="400"/>
+              </a:spcAft>
+            </a:pPr>
+            <a:r>
+              <a:rPr sz="1300" b="0">
+                <a:solidFill>
+                  <a:srgbClr val="1F2A24"/>
+                </a:solidFill>
+                <a:latin typeface="Noto Sans JP"/>
+              </a:rPr>
+              <a:t>配信前に一言だけ添えられる</a:t>
+            </a:r>
+          </a:p>
+          <a:p>
+            <a:pPr algn="l">
+              <a:spcAft>
+                <a:spcPts val="400"/>
+              </a:spcAft>
+            </a:pPr>
+            <a:r>
+              <a:rPr sz="1300" b="1">
+                <a:solidFill>
+                  <a:srgbClr val="1B3A2F"/>
+                </a:solidFill>
+                <a:latin typeface="Noto Sans JP"/>
+              </a:rPr>
+              <a:t>PDF・記録証</a:t>
+            </a:r>
+          </a:p>
+          <a:p>
+            <a:pPr algn="l">
+              <a:spcAft>
+                <a:spcPts val="400"/>
+              </a:spcAft>
+            </a:pPr>
+            <a:r>
+              <a:rPr sz="1300" b="0">
+                <a:solidFill>
+                  <a:srgbClr val="1F2A24"/>
+                </a:solidFill>
+                <a:latin typeface="Noto Sans JP"/>
+              </a:rPr>
+              <a:t>面談や月末の報告にもそのまま使える</a:t>
+            </a:r>
+          </a:p>
+        </p:txBody>
+      </p:sp>
+    </p:spTree>
+  </p:cSld>
+  <p:clrMapOvr>
+    <a:masterClrMapping/>
+  </p:clrMapOvr>
+</p:sld>
+</file>
+
+<file path=ppt/slides/slide7.xml><?xml version="1.0" encoding="utf-8"?>
+<p:sld xmlns:a="http://schemas.openxmlformats.org/drawingml/2006/main" xmlns:p="http://schemas.openxmlformats.org/presentationml/2006/main" xmlns:r="http://schemas.openxmlformats.org/officeDocument/2006/relationships">
+  <p:cSld>
+    <p:bg>
+      <p:bgPr>
+        <a:solidFill>
+          <a:srgbClr val="FAFAFA"/>
+        </a:solidFill>
+        <a:effectLst/>
+      </p:bgPr>
+    </p:bg>
+    <p:spTree>
+      <p:nvGrpSpPr>
+        <p:cNvPr id="1" name=""/>
+        <p:cNvGrpSpPr/>
+        <p:nvPr/>
+      </p:nvGrpSpPr>
+      <p:grpSpPr/>
+      <p:sp>
+        <p:nvSpPr>
+          <p:cNvPr id="2" name="TextBox 1"/>
+          <p:cNvSpPr txBox="1"/>
+          <p:nvPr/>
+        </p:nvSpPr>
+        <p:spPr>
+          <a:xfrm>
+            <a:off x="457200" y="292608"/>
+            <a:ext cx="8229600" cy="777240"/>
+          </a:xfrm>
+          <a:prstGeom prst="rect">
+            <a:avLst/>
+          </a:prstGeom>
+          <a:noFill/>
+        </p:spPr>
+        <p:txBody>
+          <a:bodyPr wrap="square" anchor="ctr" lIns="36576" rIns="36576" tIns="36576" bIns="36576">
+            <a:spAutoFit/>
+          </a:bodyPr>
+          <a:lstStyle/>
+          <a:p>
+            <a:pPr algn="l"/>
+            <a:r>
+              <a:rPr sz="2600" b="1">
+                <a:solidFill>
+                  <a:srgbClr val="1B3A2F"/>
+                </a:solidFill>
+                <a:latin typeface="Noto Sans JP"/>
+              </a:rPr>
+              <a:t>導入は4ステップ、機材は今あるiPad・PCで足りる</a:t>
+            </a:r>
+          </a:p>
+        </p:txBody>
+      </p:sp>
+      <p:sp>
+        <p:nvSpPr>
+          <p:cNvPr id="3" name="Oval 2"/>
           <p:cNvSpPr/>
           <p:nvPr/>
         </p:nvSpPr>
         <p:spPr>
           <a:xfrm>
-            <a:off x="3703320" y="1243584"/>
+            <a:off x="457200" y="1371600"/>
             <a:ext cx="457200" cy="457200"/>
           </a:xfrm>
           <a:prstGeom prst="ellipse">
@@ -4586,6 +5570,42 @@
           </a:p>
         </p:txBody>
       </p:sp>
+      <p:cxnSp>
+        <p:nvCxnSpPr>
+          <p:cNvPr id="4" name="Connector 3"/>
+          <p:cNvCxnSpPr/>
+          <p:nvPr/>
+        </p:nvCxnSpPr>
+        <p:spPr>
+          <a:xfrm>
+            <a:off x="1005840" y="1600200"/>
+            <a:ext cx="1463040" cy="0"/>
+          </a:xfrm>
+          <a:prstGeom prst="line">
+            <a:avLst/>
+          </a:prstGeom>
+          <a:ln w="25400">
+            <a:solidFill>
+              <a:srgbClr val="66756B"/>
+            </a:solidFill>
+            <a:tailEnd type="triangle"/>
+          </a:ln>
+        </p:spPr>
+        <p:style>
+          <a:lnRef idx="2">
+            <a:schemeClr val="accent1"/>
+          </a:lnRef>
+          <a:fillRef idx="0">
+            <a:schemeClr val="accent1"/>
+          </a:fillRef>
+          <a:effectRef idx="1">
+            <a:schemeClr val="accent1"/>
+          </a:effectRef>
+          <a:fontRef idx="minor">
+            <a:schemeClr val="tx1"/>
+          </a:fontRef>
+        </p:style>
+      </p:cxnSp>
       <p:sp>
         <p:nvSpPr>
           <p:cNvPr id="5" name="TextBox 4"/>
@@ -4594,8 +5614,8 @@
         </p:nvSpPr>
         <p:spPr>
           <a:xfrm>
-            <a:off x="4343400" y="1188720"/>
-            <a:ext cx="4343400" cy="822960"/>
+            <a:off x="457200" y="2011680"/>
+            <a:ext cx="1920240" cy="640080"/>
           </a:xfrm>
           <a:prstGeom prst="rect">
             <a:avLst/>
@@ -4608,11 +5628,7 @@
           </a:bodyPr>
           <a:lstStyle/>
           <a:p>
-            <a:pPr algn="l">
-              <a:spcAft>
-                <a:spcPts val="100"/>
-              </a:spcAft>
-            </a:pPr>
+            <a:pPr algn="l"/>
             <a:r>
               <a:rPr sz="1600" b="1">
                 <a:solidFill>
@@ -4620,15 +5636,34 @@
                 </a:solidFill>
                 <a:latin typeface="Noto Sans JP"/>
               </a:rPr>
-              <a:t>教室が配信を設定</a:t>
-            </a:r>
-          </a:p>
-          <a:p>
-            <a:pPr algn="l">
-              <a:spcAft>
-                <a:spcPts val="100"/>
-              </a:spcAft>
-            </a:pPr>
+              <a:t>名簿を登録</a:t>
+            </a:r>
+          </a:p>
+        </p:txBody>
+      </p:sp>
+      <p:sp>
+        <p:nvSpPr>
+          <p:cNvPr id="6" name="TextBox 5"/>
+          <p:cNvSpPr txBox="1"/>
+          <p:nvPr/>
+        </p:nvSpPr>
+        <p:spPr>
+          <a:xfrm>
+            <a:off x="457200" y="2651760"/>
+            <a:ext cx="1920240" cy="1280160"/>
+          </a:xfrm>
+          <a:prstGeom prst="rect">
+            <a:avLst/>
+          </a:prstGeom>
+          <a:noFill/>
+        </p:spPr>
+        <p:txBody>
+          <a:bodyPr wrap="square" anchor="t" lIns="36576" rIns="36576" tIns="36576" bIns="36576">
+            <a:spAutoFit/>
+          </a:bodyPr>
+          <a:lstStyle/>
+          <a:p>
+            <a:pPr algn="l"/>
             <a:r>
               <a:rPr sz="1400" b="0">
                 <a:solidFill>
@@ -4636,20 +5671,20 @@
                 </a:solidFill>
                 <a:latin typeface="Noto Sans JP"/>
               </a:rPr>
-              <a:t>毎週・隔週・毎月から選び、曜日と時刻を決める</a:t>
-            </a:r>
-          </a:p>
-        </p:txBody>
-      </p:sp>
-      <p:sp>
-        <p:nvSpPr>
-          <p:cNvPr id="6" name="Oval 5"/>
+              <a:t>CSV・Googleシートを貼るだけ。先生とプレミアムの印もここで</a:t>
+            </a:r>
+          </a:p>
+        </p:txBody>
+      </p:sp>
+      <p:sp>
+        <p:nvSpPr>
+          <p:cNvPr id="7" name="Oval 6"/>
           <p:cNvSpPr/>
           <p:nvPr/>
         </p:nvSpPr>
         <p:spPr>
           <a:xfrm>
-            <a:off x="3703320" y="2130552"/>
+            <a:off x="2560320" y="1371600"/>
             <a:ext cx="457200" cy="457200"/>
           </a:xfrm>
           <a:prstGeom prst="ellipse">
@@ -4694,16 +5729,52 @@
           </a:p>
         </p:txBody>
       </p:sp>
-      <p:sp>
-        <p:nvSpPr>
-          <p:cNvPr id="7" name="TextBox 6"/>
+      <p:cxnSp>
+        <p:nvCxnSpPr>
+          <p:cNvPr id="8" name="Connector 7"/>
+          <p:cNvCxnSpPr/>
+          <p:nvPr/>
+        </p:nvCxnSpPr>
+        <p:spPr>
+          <a:xfrm>
+            <a:off x="3108960" y="1600200"/>
+            <a:ext cx="1463040" cy="0"/>
+          </a:xfrm>
+          <a:prstGeom prst="line">
+            <a:avLst/>
+          </a:prstGeom>
+          <a:ln w="25400">
+            <a:solidFill>
+              <a:srgbClr val="66756B"/>
+            </a:solidFill>
+            <a:tailEnd type="triangle"/>
+          </a:ln>
+        </p:spPr>
+        <p:style>
+          <a:lnRef idx="2">
+            <a:schemeClr val="accent1"/>
+          </a:lnRef>
+          <a:fillRef idx="0">
+            <a:schemeClr val="accent1"/>
+          </a:fillRef>
+          <a:effectRef idx="1">
+            <a:schemeClr val="accent1"/>
+          </a:effectRef>
+          <a:fontRef idx="minor">
+            <a:schemeClr val="tx1"/>
+          </a:fontRef>
+        </p:style>
+      </p:cxnSp>
+      <p:sp>
+        <p:nvSpPr>
+          <p:cNvPr id="9" name="TextBox 8"/>
           <p:cNvSpPr txBox="1"/>
           <p:nvPr/>
         </p:nvSpPr>
         <p:spPr>
           <a:xfrm>
-            <a:off x="4343400" y="2075688"/>
-            <a:ext cx="4343400" cy="822960"/>
+            <a:off x="2560320" y="2011680"/>
+            <a:ext cx="1920240" cy="640080"/>
           </a:xfrm>
           <a:prstGeom prst="rect">
             <a:avLst/>
@@ -4716,11 +5787,7 @@
           </a:bodyPr>
           <a:lstStyle/>
           <a:p>
-            <a:pPr algn="l">
-              <a:spcAft>
-                <a:spcPts val="100"/>
-              </a:spcAft>
-            </a:pPr>
+            <a:pPr algn="l"/>
             <a:r>
               <a:rPr sz="1600" b="1">
                 <a:solidFill>
@@ -4728,15 +5795,34 @@
                 </a:solidFill>
                 <a:latin typeface="Noto Sans JP"/>
               </a:rPr>
-              <a:t>保護者がQRで登録</a:t>
-            </a:r>
-          </a:p>
-          <a:p>
-            <a:pPr algn="l">
-              <a:spcAft>
-                <a:spcPts val="100"/>
-              </a:spcAft>
-            </a:pPr>
+              <a:t>保護者にQRカードを配る</a:t>
+            </a:r>
+          </a:p>
+        </p:txBody>
+      </p:sp>
+      <p:sp>
+        <p:nvSpPr>
+          <p:cNvPr id="10" name="TextBox 9"/>
+          <p:cNvSpPr txBox="1"/>
+          <p:nvPr/>
+        </p:nvSpPr>
+        <p:spPr>
+          <a:xfrm>
+            <a:off x="2560320" y="2651760"/>
+            <a:ext cx="1920240" cy="1280160"/>
+          </a:xfrm>
+          <a:prstGeom prst="rect">
+            <a:avLst/>
+          </a:prstGeom>
+          <a:noFill/>
+        </p:spPr>
+        <p:txBody>
+          <a:bodyPr wrap="square" anchor="t" lIns="36576" rIns="36576" tIns="36576" bIns="36576">
+            <a:spAutoFit/>
+          </a:bodyPr>
+          <a:lstStyle/>
+          <a:p>
+            <a:pPr algn="l"/>
             <a:r>
               <a:rPr sz="1400" b="0">
                 <a:solidFill>
@@ -4744,20 +5830,20 @@
                 </a:solidFill>
                 <a:latin typeface="Noto Sans JP"/>
               </a:rPr>
-              <a:t>子どもごとのカードを読み取りLINEで受け取る（1人に4人まで）</a:t>
-            </a:r>
-          </a:p>
-        </p:txBody>
-      </p:sp>
-      <p:sp>
-        <p:nvSpPr>
-          <p:cNvPr id="8" name="Oval 7"/>
+              <a:t>印刷用のカードを教室ページから出力</a:t>
+            </a:r>
+          </a:p>
+        </p:txBody>
+      </p:sp>
+      <p:sp>
+        <p:nvSpPr>
+          <p:cNvPr id="11" name="Oval 10"/>
           <p:cNvSpPr/>
           <p:nvPr/>
         </p:nvSpPr>
         <p:spPr>
           <a:xfrm>
-            <a:off x="3703320" y="3017520"/>
+            <a:off x="4663440" y="1371600"/>
             <a:ext cx="457200" cy="457200"/>
           </a:xfrm>
           <a:prstGeom prst="ellipse">
@@ -4802,16 +5888,52 @@
           </a:p>
         </p:txBody>
       </p:sp>
-      <p:sp>
-        <p:nvSpPr>
-          <p:cNvPr id="9" name="TextBox 8"/>
+      <p:cxnSp>
+        <p:nvCxnSpPr>
+          <p:cNvPr id="12" name="Connector 11"/>
+          <p:cNvCxnSpPr/>
+          <p:nvPr/>
+        </p:nvCxnSpPr>
+        <p:spPr>
+          <a:xfrm>
+            <a:off x="5212079" y="1600200"/>
+            <a:ext cx="1463041" cy="0"/>
+          </a:xfrm>
+          <a:prstGeom prst="line">
+            <a:avLst/>
+          </a:prstGeom>
+          <a:ln w="25400">
+            <a:solidFill>
+              <a:srgbClr val="66756B"/>
+            </a:solidFill>
+            <a:tailEnd type="triangle"/>
+          </a:ln>
+        </p:spPr>
+        <p:style>
+          <a:lnRef idx="2">
+            <a:schemeClr val="accent1"/>
+          </a:lnRef>
+          <a:fillRef idx="0">
+            <a:schemeClr val="accent1"/>
+          </a:fillRef>
+          <a:effectRef idx="1">
+            <a:schemeClr val="accent1"/>
+          </a:effectRef>
+          <a:fontRef idx="minor">
+            <a:schemeClr val="tx1"/>
+          </a:fontRef>
+        </p:style>
+      </p:cxnSp>
+      <p:sp>
+        <p:nvSpPr>
+          <p:cNvPr id="13" name="TextBox 12"/>
           <p:cNvSpPr txBox="1"/>
           <p:nvPr/>
         </p:nvSpPr>
         <p:spPr>
           <a:xfrm>
-            <a:off x="4343400" y="2962656"/>
-            <a:ext cx="4343400" cy="822960"/>
+            <a:off x="4663440" y="2011680"/>
+            <a:ext cx="1920240" cy="640080"/>
           </a:xfrm>
           <a:prstGeom prst="rect">
             <a:avLst/>
@@ -4824,11 +5946,7 @@
           </a:bodyPr>
           <a:lstStyle/>
           <a:p>
-            <a:pPr algn="l">
-              <a:spcAft>
-                <a:spcPts val="100"/>
-              </a:spcAft>
-            </a:pPr>
+            <a:pPr algn="l"/>
             <a:r>
               <a:rPr sz="1600" b="1">
                 <a:solidFill>
@@ -4836,15 +5954,34 @@
                 </a:solidFill>
                 <a:latin typeface="Noto Sans JP"/>
               </a:rPr>
-              <a:t>レポートを自動作成して配信</a:t>
-            </a:r>
-          </a:p>
-          <a:p>
-            <a:pPr algn="l">
-              <a:spcAft>
-                <a:spcPts val="100"/>
-              </a:spcAft>
-            </a:pPr>
+              <a:t>授業で一緒に始める</a:t>
+            </a:r>
+          </a:p>
+        </p:txBody>
+      </p:sp>
+      <p:sp>
+        <p:nvSpPr>
+          <p:cNvPr id="14" name="TextBox 13"/>
+          <p:cNvSpPr txBox="1"/>
+          <p:nvPr/>
+        </p:nvSpPr>
+        <p:spPr>
+          <a:xfrm>
+            <a:off x="4663440" y="2651760"/>
+            <a:ext cx="1920240" cy="1280160"/>
+          </a:xfrm>
+          <a:prstGeom prst="rect">
+            <a:avLst/>
+          </a:prstGeom>
+          <a:noFill/>
+        </p:spPr>
+        <p:txBody>
+          <a:bodyPr wrap="square" anchor="t" lIns="36576" rIns="36576" tIns="36576" bIns="36576">
+            <a:spAutoFit/>
+          </a:bodyPr>
+          <a:lstStyle/>
+          <a:p>
+            <a:pPr algn="l"/>
             <a:r>
               <a:rPr sz="1400" b="0">
                 <a:solidFill>
@@ -4852,20 +5989,20 @@
                 </a:solidFill>
                 <a:latin typeface="Noto Sans JP"/>
               </a:rPr>
-              <a:t>英語をした日・答えた数・覚えた単語・来週のめあて</a:t>
-            </a:r>
-          </a:p>
-        </p:txBody>
-      </p:sp>
-      <p:sp>
-        <p:nvSpPr>
-          <p:cNvPr id="10" name="Oval 9"/>
+              <a:t>授業モードでクラス全員を同じ島に集める</a:t>
+            </a:r>
+          </a:p>
+        </p:txBody>
+      </p:sp>
+      <p:sp>
+        <p:nvSpPr>
+          <p:cNvPr id="15" name="Oval 14"/>
           <p:cNvSpPr/>
           <p:nvPr/>
         </p:nvSpPr>
         <p:spPr>
           <a:xfrm>
-            <a:off x="3703320" y="3904488"/>
+            <a:off x="6766559" y="1371600"/>
             <a:ext cx="457200" cy="457200"/>
           </a:xfrm>
           <a:prstGeom prst="ellipse">
@@ -4912,14 +6049,14 @@
       </p:sp>
       <p:sp>
         <p:nvSpPr>
-          <p:cNvPr id="11" name="TextBox 10"/>
+          <p:cNvPr id="16" name="TextBox 15"/>
           <p:cNvSpPr txBox="1"/>
           <p:nvPr/>
         </p:nvSpPr>
         <p:spPr>
           <a:xfrm>
-            <a:off x="4343400" y="3849624"/>
-            <a:ext cx="4343400" cy="822960"/>
+            <a:off x="6766559" y="2011680"/>
+            <a:ext cx="1920240" cy="640080"/>
           </a:xfrm>
           <a:prstGeom prst="rect">
             <a:avLst/>
@@ -4932,35 +6069,324 @@
           </a:bodyPr>
           <a:lstStyle/>
           <a:p>
+            <a:pPr algn="l"/>
+            <a:r>
+              <a:rPr sz="1600" b="1">
+                <a:solidFill>
+                  <a:srgbClr val="1B3A2F"/>
+                </a:solidFill>
+                <a:latin typeface="Noto Sans JP"/>
+              </a:rPr>
+              <a:t>LINE配信を設定</a:t>
+            </a:r>
+          </a:p>
+        </p:txBody>
+      </p:sp>
+      <p:sp>
+        <p:nvSpPr>
+          <p:cNvPr id="17" name="TextBox 16"/>
+          <p:cNvSpPr txBox="1"/>
+          <p:nvPr/>
+        </p:nvSpPr>
+        <p:spPr>
+          <a:xfrm>
+            <a:off x="6766559" y="2651760"/>
+            <a:ext cx="1920240" cy="1280160"/>
+          </a:xfrm>
+          <a:prstGeom prst="rect">
+            <a:avLst/>
+          </a:prstGeom>
+          <a:noFill/>
+        </p:spPr>
+        <p:txBody>
+          <a:bodyPr wrap="square" anchor="t" lIns="36576" rIns="36576" tIns="36576" bIns="36576">
+            <a:spAutoFit/>
+          </a:bodyPr>
+          <a:lstStyle/>
+          <a:p>
+            <a:pPr algn="l"/>
+            <a:r>
+              <a:rPr sz="1400" b="0">
+                <a:solidFill>
+                  <a:srgbClr val="1F2A24"/>
+                </a:solidFill>
+                <a:latin typeface="Noto Sans JP"/>
+              </a:rPr>
+              <a:t>毎週・隔週・毎月から選び、曜日と時刻を決める</a:t>
+            </a:r>
+          </a:p>
+        </p:txBody>
+      </p:sp>
+      <p:sp>
+        <p:nvSpPr>
+          <p:cNvPr id="18" name="Rounded Rectangle 17"/>
+          <p:cNvSpPr/>
+          <p:nvPr/>
+        </p:nvSpPr>
+        <p:spPr>
+          <a:xfrm>
+            <a:off x="457200" y="3931920"/>
+            <a:ext cx="8229600" cy="685800"/>
+          </a:xfrm>
+          <a:prstGeom prst="roundRect">
+            <a:avLst/>
+          </a:prstGeom>
+          <a:solidFill>
+            <a:srgbClr val="FFF1E3"/>
+          </a:solidFill>
+          <a:ln>
+            <a:noFill/>
+          </a:ln>
+          <a:effectLst/>
+        </p:spPr>
+        <p:style>
+          <a:lnRef idx="1">
+            <a:schemeClr val="accent1"/>
+          </a:lnRef>
+          <a:fillRef idx="3">
+            <a:schemeClr val="accent1"/>
+          </a:fillRef>
+          <a:effectRef idx="2">
+            <a:schemeClr val="accent1"/>
+          </a:effectRef>
+          <a:fontRef idx="minor">
+            <a:schemeClr val="lt1"/>
+          </a:fontRef>
+        </p:style>
+        <p:txBody>
+          <a:bodyPr rtlCol="0" anchor="ctr"/>
+          <a:lstStyle/>
+          <a:p>
+            <a:pPr algn="ctr"/>
+          </a:p>
+        </p:txBody>
+      </p:sp>
+      <p:sp>
+        <p:nvSpPr>
+          <p:cNvPr id="19" name="TextBox 18"/>
+          <p:cNvSpPr txBox="1"/>
+          <p:nvPr/>
+        </p:nvSpPr>
+        <p:spPr>
+          <a:xfrm>
+            <a:off x="685800" y="4005072"/>
+            <a:ext cx="7863840" cy="548640"/>
+          </a:xfrm>
+          <a:prstGeom prst="rect">
+            <a:avLst/>
+          </a:prstGeom>
+          <a:noFill/>
+        </p:spPr>
+        <p:txBody>
+          <a:bodyPr wrap="square" anchor="ctr" lIns="36576" rIns="36576" tIns="36576" bIns="36576">
+            <a:spAutoFit/>
+          </a:bodyPr>
+          <a:lstStyle/>
+          <a:p>
+            <a:pPr algn="l"/>
+            <a:r>
+              <a:rPr sz="1400" b="0">
+                <a:solidFill>
+                  <a:srgbClr val="1F2A24"/>
+                </a:solidFill>
+                <a:latin typeface="Noto Sans JP"/>
+              </a:rPr>
+              <a:t>料金は教室の人数とプランに合わせてご提案します。AI英会話・英検の島はプレミアム（生徒ごとに設定）。</a:t>
+            </a:r>
+          </a:p>
+        </p:txBody>
+      </p:sp>
+    </p:spTree>
+  </p:cSld>
+  <p:clrMapOvr>
+    <a:masterClrMapping/>
+  </p:clrMapOvr>
+</p:sld>
+</file>
+
+<file path=ppt/slides/slide8.xml><?xml version="1.0" encoding="utf-8"?>
+<p:sld xmlns:a="http://schemas.openxmlformats.org/drawingml/2006/main" xmlns:p="http://schemas.openxmlformats.org/presentationml/2006/main" xmlns:r="http://schemas.openxmlformats.org/officeDocument/2006/relationships">
+  <p:cSld>
+    <p:bg>
+      <p:bgPr>
+        <a:solidFill>
+          <a:srgbClr val="FAFAFA"/>
+        </a:solidFill>
+        <a:effectLst/>
+      </p:bgPr>
+    </p:bg>
+    <p:spTree>
+      <p:nvGrpSpPr>
+        <p:cNvPr id="1" name=""/>
+        <p:cNvGrpSpPr/>
+        <p:nvPr/>
+      </p:nvGrpSpPr>
+      <p:grpSpPr/>
+      <p:sp>
+        <p:nvSpPr>
+          <p:cNvPr id="2" name="Rectangle 1"/>
+          <p:cNvSpPr/>
+          <p:nvPr/>
+        </p:nvSpPr>
+        <p:spPr>
+          <a:xfrm>
+            <a:off x="0" y="0"/>
+            <a:ext cx="9144000" cy="5143500"/>
+          </a:xfrm>
+          <a:prstGeom prst="rect">
+            <a:avLst/>
+          </a:prstGeom>
+          <a:solidFill>
+            <a:srgbClr val="1B3A2F"/>
+          </a:solidFill>
+          <a:ln>
+            <a:noFill/>
+          </a:ln>
+          <a:effectLst/>
+        </p:spPr>
+        <p:style>
+          <a:lnRef idx="1">
+            <a:schemeClr val="accent1"/>
+          </a:lnRef>
+          <a:fillRef idx="3">
+            <a:schemeClr val="accent1"/>
+          </a:fillRef>
+          <a:effectRef idx="2">
+            <a:schemeClr val="accent1"/>
+          </a:effectRef>
+          <a:fontRef idx="minor">
+            <a:schemeClr val="lt1"/>
+          </a:fontRef>
+        </p:style>
+        <p:txBody>
+          <a:bodyPr rtlCol="0" anchor="ctr"/>
+          <a:lstStyle/>
+          <a:p>
+            <a:pPr algn="ctr"/>
+          </a:p>
+        </p:txBody>
+      </p:sp>
+      <p:sp>
+        <p:nvSpPr>
+          <p:cNvPr id="3" name="TextBox 2"/>
+          <p:cNvSpPr txBox="1"/>
+          <p:nvPr/>
+        </p:nvSpPr>
+        <p:spPr>
+          <a:xfrm>
+            <a:off x="731520" y="1188720"/>
+            <a:ext cx="7680960" cy="822960"/>
+          </a:xfrm>
+          <a:prstGeom prst="rect">
+            <a:avLst/>
+          </a:prstGeom>
+          <a:noFill/>
+        </p:spPr>
+        <p:txBody>
+          <a:bodyPr wrap="square" anchor="t" lIns="36576" rIns="36576" tIns="36576" bIns="36576">
+            <a:spAutoFit/>
+          </a:bodyPr>
+          <a:lstStyle/>
+          <a:p>
+            <a:pPr algn="l"/>
+            <a:r>
+              <a:rPr sz="2800" b="1">
+                <a:solidFill>
+                  <a:srgbClr val="FFF6E6"/>
+                </a:solidFill>
+                <a:latin typeface="Noto Sans JP"/>
+              </a:rPr>
+              <a:t>まずは30分のデモで、実際の画面を一緒に動かしてみませんか</a:t>
+            </a:r>
+          </a:p>
+        </p:txBody>
+      </p:sp>
+      <p:sp>
+        <p:nvSpPr>
+          <p:cNvPr id="4" name="TextBox 3"/>
+          <p:cNvSpPr txBox="1"/>
+          <p:nvPr/>
+        </p:nvSpPr>
+        <p:spPr>
+          <a:xfrm>
+            <a:off x="731520" y="2377440"/>
+            <a:ext cx="7680960" cy="1463040"/>
+          </a:xfrm>
+          <a:prstGeom prst="rect">
+            <a:avLst/>
+          </a:prstGeom>
+          <a:noFill/>
+        </p:spPr>
+        <p:txBody>
+          <a:bodyPr wrap="square" anchor="t" lIns="36576" rIns="36576" tIns="36576" bIns="36576">
+            <a:spAutoFit/>
+          </a:bodyPr>
+          <a:lstStyle/>
+          <a:p>
             <a:pPr algn="l">
               <a:spcAft>
-                <a:spcPts val="100"/>
+                <a:spcPts val="600"/>
               </a:spcAft>
             </a:pPr>
             <a:r>
-              <a:rPr sz="1600" b="1">
-                <a:solidFill>
-                  <a:srgbClr val="1B3A2F"/>
-                </a:solidFill>
-                <a:latin typeface="Noto Sans JP"/>
-              </a:rPr>
-              <a:t>先生のひとことを添える</a:t>
+              <a:rPr sz="1600" b="0">
+                <a:solidFill>
+                  <a:srgbClr val="DCE6DF"/>
+                </a:solidFill>
+                <a:latin typeface="Noto Sans JP"/>
+              </a:rPr>
+              <a:t>先生の端末と生徒の端末を並べて、授業モード・ランキング・保護者レポートまで通しでお見せします。</a:t>
             </a:r>
           </a:p>
           <a:p>
             <a:pPr algn="l">
               <a:spcAft>
-                <a:spcPts val="100"/>
+                <a:spcPts val="600"/>
               </a:spcAft>
             </a:pPr>
             <a:r>
-              <a:rPr sz="1400" b="0">
-                <a:solidFill>
-                  <a:srgbClr val="1F2A24"/>
-                </a:solidFill>
-                <a:latin typeface="Noto Sans JP"/>
-              </a:rPr>
-              <a:t>クラスの順位も1行で載る。PDFでも見られる</a:t>
+              <a:rPr sz="1600" b="0">
+                <a:solidFill>
+                  <a:srgbClr val="DCE6DF"/>
+                </a:solidFill>
+                <a:latin typeface="Noto Sans JP"/>
+              </a:rPr>
+              <a:t>デモ用のクラスはこちらで用意します。</a:t>
+            </a:r>
+          </a:p>
+        </p:txBody>
+      </p:sp>
+      <p:sp>
+        <p:nvSpPr>
+          <p:cNvPr id="5" name="TextBox 4"/>
+          <p:cNvSpPr txBox="1"/>
+          <p:nvPr/>
+        </p:nvSpPr>
+        <p:spPr>
+          <a:xfrm>
+            <a:off x="731520" y="4023360"/>
+            <a:ext cx="7680960" cy="457200"/>
+          </a:xfrm>
+          <a:prstGeom prst="rect">
+            <a:avLst/>
+          </a:prstGeom>
+          <a:noFill/>
+        </p:spPr>
+        <p:txBody>
+          <a:bodyPr wrap="square" anchor="t" lIns="36576" rIns="36576" tIns="36576" bIns="36576">
+            <a:spAutoFit/>
+          </a:bodyPr>
+          <a:lstStyle/>
+          <a:p>
+            <a:pPr algn="l"/>
+            <a:r>
+              <a:rPr sz="1400" b="1">
+                <a:solidFill>
+                  <a:srgbClr val="E27A2D"/>
+                </a:solidFill>
+                <a:latin typeface="Noto Sans JP"/>
+              </a:rPr>
+              <a:t>合同会社 U-Speak Lab　|　https://uspeak-multiplayer.fly.dev</a:t>
             </a:r>
           </a:p>
         </p:txBody>

</xml_diff>